<commit_message>
feat(ui): complete dark workspace redesign with theme switch, interactive view navigation, and verified Gemma 4 engine status
</commit_message>
<xml_diff>
--- a/submission/IssueLift_Submission.pptx
+++ b/submission/IssueLift_Submission.pptx
@@ -1480,7 +1480,7 @@
     <p:bg>
       <p:bgPr>
         <a:solidFill>
-          <a:srgbClr val="F7F6FF"/>
+          <a:srgbClr val="0B1020"/>
         </a:solidFill>
       </p:bgPr>
     </p:bg>
@@ -1525,7 +1525,7 @@
             <a:r>
               <a:rPr lang="en-US" sz="1200" b="1" dirty="0">
                 <a:solidFill>
-                  <a:srgbClr val="7057F5"/>
+                  <a:srgbClr val="A78BFA"/>
                 </a:solidFill>
                 <a:latin typeface="Arial" pitchFamily="34" charset="0"/>
                 <a:ea typeface="Arial" pitchFamily="34" charset="-122"/>
@@ -1564,7 +1564,7 @@
             <a:r>
               <a:rPr lang="en-US" sz="4400" b="1" dirty="0">
                 <a:solidFill>
-                  <a:srgbClr val="17152D"/>
+                  <a:srgbClr val="F1F5F9"/>
                 </a:solidFill>
                 <a:latin typeface="Arial" pitchFamily="34" charset="0"/>
                 <a:ea typeface="Arial" pitchFamily="34" charset="-122"/>
@@ -1603,7 +1603,7 @@
             <a:r>
               <a:rPr lang="en-US" sz="2000" dirty="0">
                 <a:solidFill>
-                  <a:srgbClr val="477BFF"/>
+                  <a:srgbClr val="60A5FA"/>
                 </a:solidFill>
                 <a:latin typeface="Arial" pitchFamily="34" charset="0"/>
                 <a:ea typeface="Arial" pitchFamily="34" charset="-122"/>
@@ -1667,7 +1667,7 @@
             <a:r>
               <a:rPr lang="en-US" sz="1400" b="1" dirty="0">
                 <a:solidFill>
-                  <a:srgbClr val="7057F5"/>
+                  <a:srgbClr val="A78BFA"/>
                 </a:solidFill>
                 <a:latin typeface="Arial" pitchFamily="34" charset="0"/>
                 <a:ea typeface="Arial" pitchFamily="34" charset="-122"/>
@@ -1709,7 +1709,7 @@
             <a:r>
               <a:rPr lang="en-US" sz="1300" dirty="0">
                 <a:solidFill>
-                  <a:srgbClr val="17152D"/>
+                  <a:srgbClr val="F1F5F9"/>
                 </a:solidFill>
                 <a:latin typeface="Arial" pitchFamily="34" charset="0"/>
                 <a:ea typeface="Arial" pitchFamily="34" charset="-122"/>
@@ -1738,7 +1738,7 @@
             <a:r>
               <a:rPr lang="en-US" sz="1300" dirty="0">
                 <a:solidFill>
-                  <a:srgbClr val="17152D"/>
+                  <a:srgbClr val="F1F5F9"/>
                 </a:solidFill>
                 <a:latin typeface="Arial" pitchFamily="34" charset="0"/>
                 <a:ea typeface="Arial" pitchFamily="34" charset="-122"/>
@@ -1767,7 +1767,7 @@
             <a:r>
               <a:rPr lang="en-US" sz="1300" dirty="0">
                 <a:solidFill>
-                  <a:srgbClr val="17152D"/>
+                  <a:srgbClr val="F1F5F9"/>
                 </a:solidFill>
                 <a:latin typeface="Arial" pitchFamily="34" charset="0"/>
                 <a:ea typeface="Arial" pitchFamily="34" charset="-122"/>
@@ -1793,7 +1793,7 @@
     <p:bg>
       <p:bgPr>
         <a:solidFill>
-          <a:srgbClr val="F7F6FF"/>
+          <a:srgbClr val="0B1020"/>
         </a:solidFill>
       </p:bgPr>
     </p:bg>
@@ -1838,7 +1838,7 @@
             <a:r>
               <a:rPr lang="en-US" sz="1200" b="1" dirty="0">
                 <a:solidFill>
-                  <a:srgbClr val="7057F5"/>
+                  <a:srgbClr val="A78BFA"/>
                 </a:solidFill>
                 <a:latin typeface="Arial" pitchFamily="34" charset="0"/>
                 <a:ea typeface="Arial" pitchFamily="34" charset="-122"/>
@@ -1877,7 +1877,7 @@
             <a:r>
               <a:rPr lang="en-US" sz="2600" b="1" dirty="0">
                 <a:solidFill>
-                  <a:srgbClr val="17152D"/>
+                  <a:srgbClr val="F1F5F9"/>
                 </a:solidFill>
                 <a:latin typeface="Arial" pitchFamily="34" charset="0"/>
                 <a:ea typeface="Arial" pitchFamily="34" charset="-122"/>
@@ -3257,7 +3257,7 @@
     <p:bg>
       <p:bgPr>
         <a:solidFill>
-          <a:srgbClr val="F7F6FF"/>
+          <a:srgbClr val="0B1020"/>
         </a:solidFill>
       </p:bgPr>
     </p:bg>
@@ -3302,7 +3302,7 @@
             <a:r>
               <a:rPr lang="en-US" sz="1200" b="1" dirty="0">
                 <a:solidFill>
-                  <a:srgbClr val="7057F5"/>
+                  <a:srgbClr val="A78BFA"/>
                 </a:solidFill>
                 <a:latin typeface="Arial" pitchFamily="34" charset="0"/>
                 <a:ea typeface="Arial" pitchFamily="34" charset="-122"/>
@@ -3341,7 +3341,7 @@
             <a:r>
               <a:rPr lang="en-US" sz="2600" b="1" dirty="0">
                 <a:solidFill>
-                  <a:srgbClr val="17152D"/>
+                  <a:srgbClr val="F1F5F9"/>
                 </a:solidFill>
                 <a:latin typeface="Arial" pitchFamily="34" charset="0"/>
                 <a:ea typeface="Arial" pitchFamily="34" charset="-122"/>
@@ -3405,7 +3405,7 @@
             <a:r>
               <a:rPr lang="en-US" sz="1600" b="1" dirty="0">
                 <a:solidFill>
-                  <a:srgbClr val="7057F5"/>
+                  <a:srgbClr val="A78BFA"/>
                 </a:solidFill>
               </a:rPr>
               <a:t>1. Explicit vs. Inferred</a:t>
@@ -3444,7 +3444,7 @@
             <a:r>
               <a:rPr lang="en-US" sz="1200" dirty="0">
                 <a:solidFill>
-                  <a:srgbClr val="17152D"/>
+                  <a:srgbClr val="F1F5F9"/>
                 </a:solidFill>
               </a:rPr>
               <a:t>• Explicit Quotes: Direct issue excerpts are retained verbatim as AC-01, AC-02, etc. and linked to GitHub.</a:t>
@@ -3470,7 +3470,7 @@
             <a:r>
               <a:rPr lang="en-US" sz="1200" dirty="0">
                 <a:solidFill>
-                  <a:srgbClr val="17152D"/>
+                  <a:srgbClr val="F1F5F9"/>
                 </a:solidFill>
               </a:rPr>
               <a:t>• AI-Proposed: Missing requirements are clearly labelled AI-INFERRED. Never masquerade as maintainer approved.</a:t>
@@ -3496,7 +3496,7 @@
             <a:r>
               <a:rPr lang="en-US" sz="1200" dirty="0">
                 <a:solidFill>
-                  <a:srgbClr val="17152D"/>
+                  <a:srgbClr val="F1F5F9"/>
                 </a:solidFill>
               </a:rPr>
               <a:t>• In-Memory Editing: Contributor can edit criteria or toggle "Needs Clarification" without database overhead.</a:t>
@@ -3557,7 +3557,7 @@
             <a:r>
               <a:rPr lang="en-US" sz="1600" b="1" dirty="0">
                 <a:solidFill>
-                  <a:srgbClr val="477BFF"/>
+                  <a:srgbClr val="60A5FA"/>
                 </a:solidFill>
               </a:rPr>
               <a:t>2. Readiness Gate</a:t>
@@ -3596,7 +3596,7 @@
             <a:r>
               <a:rPr lang="en-US" sz="1200" dirty="0">
                 <a:solidFill>
-                  <a:srgbClr val="17152D"/>
+                  <a:srgbClr val="F1F5F9"/>
                 </a:solidFill>
               </a:rPr>
               <a:t>• ACTIONABLE: Issue open, unassigned, candidate source files identified, test evidence mapped.</a:t>
@@ -3622,7 +3622,7 @@
             <a:r>
               <a:rPr lang="en-US" sz="1200" dirty="0">
                 <a:solidFill>
-                  <a:srgbClr val="17152D"/>
+                  <a:srgbClr val="F1F5F9"/>
                 </a:solidFill>
               </a:rPr>
               <a:t>• CLARIFY FIRST: Closed on GitHub, assigned to another engineer, or ambiguous criteria require maintainer confirmation.</a:t>
@@ -3648,7 +3648,7 @@
             <a:r>
               <a:rPr lang="en-US" sz="1200" dirty="0">
                 <a:solidFill>
-                  <a:srgbClr val="17152D"/>
+                  <a:srgbClr val="F1F5F9"/>
                 </a:solidFill>
               </a:rPr>
               <a:t>• EVIDENCE-LIMITED: Truncated repository tree or missing setup documentation disclosed honestly.</a:t>
@@ -3709,7 +3709,7 @@
             <a:r>
               <a:rPr lang="en-US" sz="1600" b="1" dirty="0">
                 <a:solidFill>
-                  <a:srgbClr val="26C7C9"/>
+                  <a:srgbClr val="2DD4BF"/>
                 </a:solidFill>
               </a:rPr>
               <a:t>3. Copy-Ready Handoff</a:t>
@@ -3748,7 +3748,7 @@
             <a:r>
               <a:rPr lang="en-US" sz="1200" dirty="0">
                 <a:solidFill>
-                  <a:srgbClr val="17152D"/>
+                  <a:srgbClr val="F1F5F9"/>
                 </a:solidFill>
               </a:rPr>
               <a:t>• Specific Question: Cites the exact triggering ambiguity from the issue, not generic conversational filler.</a:t>
@@ -3774,7 +3774,7 @@
             <a:r>
               <a:rPr lang="en-US" sz="1200" dirty="0">
                 <a:solidFill>
-                  <a:srgbClr val="17152D"/>
+                  <a:srgbClr val="F1F5F9"/>
                 </a:solidFill>
               </a:rPr>
               <a:t>• Proposed Additions: Drafts concrete acceptance criteria additions for maintainer blessing.</a:t>
@@ -3800,7 +3800,7 @@
             <a:r>
               <a:rPr lang="en-US" sz="1200" dirty="0">
                 <a:solidFill>
-                  <a:srgbClr val="17152D"/>
+                  <a:srgbClr val="F1F5F9"/>
                 </a:solidFill>
               </a:rPr>
               <a:t>• Never Auto-Posts: Contributor edits and copies to clipboard manually. Respects maintainer space.</a:t>
@@ -3823,7 +3823,7 @@
     <p:bg>
       <p:bgPr>
         <a:solidFill>
-          <a:srgbClr val="F7F6FF"/>
+          <a:srgbClr val="0B1020"/>
         </a:solidFill>
       </p:bgPr>
     </p:bg>
@@ -3868,7 +3868,7 @@
             <a:r>
               <a:rPr lang="en-US" sz="1200" b="1" dirty="0">
                 <a:solidFill>
-                  <a:srgbClr val="7057F5"/>
+                  <a:srgbClr val="A78BFA"/>
                 </a:solidFill>
                 <a:latin typeface="Arial" pitchFamily="34" charset="0"/>
                 <a:ea typeface="Arial" pitchFamily="34" charset="-122"/>
@@ -3907,7 +3907,7 @@
             <a:r>
               <a:rPr lang="en-US" sz="2600" b="1" dirty="0">
                 <a:solidFill>
-                  <a:srgbClr val="17152D"/>
+                  <a:srgbClr val="F1F5F9"/>
                 </a:solidFill>
                 <a:latin typeface="Arial" pitchFamily="34" charset="0"/>
                 <a:ea typeface="Arial" pitchFamily="34" charset="-122"/>
@@ -3971,7 +3971,7 @@
             <a:r>
               <a:rPr lang="en-US" sz="1500" b="1" dirty="0">
                 <a:solidFill>
-                  <a:srgbClr val="7057F5"/>
+                  <a:srgbClr val="A78BFA"/>
                 </a:solidFill>
               </a:rPr>
               <a:t>4-NODE VERIFIED EVIDENCE CHAINS &amp; HONEST CAVEATS</a:t>
@@ -4010,7 +4010,7 @@
             <a:r>
               <a:rPr lang="en-US" sz="1300" dirty="0">
                 <a:solidFill>
-                  <a:srgbClr val="17152D"/>
+                  <a:srgbClr val="F1F5F9"/>
                 </a:solidFill>
               </a:rPr>
               <a:t>1. Requirement Node: Explicit issue quote (e.g. AC-01) with link back to GitHub discussion.</a:t>
@@ -4036,7 +4036,7 @@
             <a:r>
               <a:rPr lang="en-US" sz="1300" dirty="0">
                 <a:solidFill>
-                  <a:srgbClr val="17152D"/>
+                  <a:srgbClr val="F1F5F9"/>
                 </a:solidFill>
               </a:rPr>
               <a:t>2. Candidate Implementation Node: File path confirmed in fetched repository tree. Path existence is VERIFIED; relevance remains AI-INFERRED until validated.</a:t>
@@ -4062,7 +4062,7 @@
             <a:r>
               <a:rPr lang="en-US" sz="1300" dirty="0">
                 <a:solidFill>
-                  <a:srgbClr val="17152D"/>
+                  <a:srgbClr val="F1F5F9"/>
                 </a:solidFill>
               </a:rPr>
               <a:t>3. Candidate Test Node: Test file or spec candidate identified. Status: TEST EVIDENCE FOUND, or NO TEST EVIDENCE FOUND IN SCANNED FILES.</a:t>
@@ -4088,7 +4088,7 @@
             <a:r>
               <a:rPr lang="en-US" sz="1300" dirty="0">
                 <a:solidFill>
-                  <a:srgbClr val="17152D"/>
+                  <a:srgbClr val="F1F5F9"/>
                 </a:solidFill>
               </a:rPr>
               <a:t>4. Documented Test Command: Documented npm/cargo/pytest command extracted from README/CONTRIBUTING with direct file citation.</a:t>
@@ -4114,7 +4114,7 @@
             <a:r>
               <a:rPr lang="en-US" sz="1300" dirty="0">
                 <a:solidFill>
-                  <a:srgbClr val="17152D"/>
+                  <a:srgbClr val="F1F5F9"/>
                 </a:solidFill>
               </a:rPr>
               <a:t>• TEST GAP RADAR: When no test evidence is identified in the scanned files, IssueLift generates a Test Gap card explaining what was checked, why uncertainty exists, and proposing a manual verification scenario. It NEVER claims "no tests exist" or fabricates coverage percentages.</a:t>
@@ -4137,7 +4137,7 @@
     <p:bg>
       <p:bgPr>
         <a:solidFill>
-          <a:srgbClr val="F7F6FF"/>
+          <a:srgbClr val="0B1020"/>
         </a:solidFill>
       </p:bgPr>
     </p:bg>
@@ -4182,7 +4182,7 @@
             <a:r>
               <a:rPr lang="en-US" sz="1200" b="1" dirty="0">
                 <a:solidFill>
-                  <a:srgbClr val="7057F5"/>
+                  <a:srgbClr val="A78BFA"/>
                 </a:solidFill>
                 <a:latin typeface="Arial" pitchFamily="34" charset="0"/>
                 <a:ea typeface="Arial" pitchFamily="34" charset="-122"/>
@@ -4221,7 +4221,7 @@
             <a:r>
               <a:rPr lang="en-US" sz="2600" b="1" dirty="0">
                 <a:solidFill>
-                  <a:srgbClr val="17152D"/>
+                  <a:srgbClr val="F1F5F9"/>
                 </a:solidFill>
                 <a:latin typeface="Arial" pitchFamily="34" charset="0"/>
                 <a:ea typeface="Arial" pitchFamily="34" charset="-122"/>
@@ -4285,7 +4285,7 @@
             <a:r>
               <a:rPr lang="en-US" sz="1600" b="1" dirty="0">
                 <a:solidFill>
-                  <a:srgbClr val="477BFF"/>
+                  <a:srgbClr val="60A5FA"/>
                 </a:solidFill>
               </a:rPr>
               <a:t>Gemma 4 Reasoning Engine</a:t>
@@ -4324,7 +4324,7 @@
             <a:r>
               <a:rPr lang="en-US" sz="1200" dirty="0">
                 <a:solidFill>
-                  <a:srgbClr val="17152D"/>
+                  <a:srgbClr val="F1F5F9"/>
                 </a:solidFill>
               </a:rPr>
               <a:t>• Server-Side Integration: Official @google/genai SDK on Next.js server route handlers.</a:t>
@@ -4350,7 +4350,7 @@
             <a:r>
               <a:rPr lang="en-US" sz="1200" dirty="0">
                 <a:solidFill>
-                  <a:srgbClr val="17152D"/>
+                  <a:srgbClr val="F1F5F9"/>
                 </a:solidFill>
               </a:rPr>
               <a:t>• Verified Model: gemma-4-26b-a4b-it via Google AI Studio free tier.</a:t>
@@ -4376,7 +4376,7 @@
             <a:r>
               <a:rPr lang="en-US" sz="1200" dirty="0">
                 <a:solidFill>
-                  <a:srgbClr val="17152D"/>
+                  <a:srgbClr val="F1F5F9"/>
                 </a:solidFill>
               </a:rPr>
               <a:t>• Secret Isolation: GEMMA_API_KEY is never leaked to browser, git, or client bundles.</a:t>
@@ -4402,7 +4402,7 @@
             <a:r>
               <a:rPr lang="en-US" sz="1200" dirty="0">
                 <a:solidFill>
-                  <a:srgbClr val="17152D"/>
+                  <a:srgbClr val="F1F5F9"/>
                 </a:solidFill>
               </a:rPr>
               <a:t>• Prompt Injection Defense: Issue body and comments are explicitly isolated as untrusted data.</a:t>
@@ -4428,7 +4428,7 @@
             <a:r>
               <a:rPr lang="en-US" sz="1200" dirty="0">
                 <a:solidFill>
-                  <a:srgbClr val="17152D"/>
+                  <a:srgbClr val="F1F5F9"/>
                 </a:solidFill>
               </a:rPr>
               <a:t>• Structured Zod Schema: Validates requirement criteria, status rationales, and handoff questions.</a:t>
@@ -4489,7 +4489,7 @@
             <a:r>
               <a:rPr lang="en-US" sz="1600" b="1" dirty="0">
                 <a:solidFill>
-                  <a:srgbClr val="26C7C9"/>
+                  <a:srgbClr val="2DD4BF"/>
                 </a:solidFill>
               </a:rPr>
               <a:t>Deterministic Claim Gate</a:t>
@@ -4528,7 +4528,7 @@
             <a:r>
               <a:rPr lang="en-US" sz="1200" dirty="0">
                 <a:solidFill>
-                  <a:srgbClr val="17152D"/>
+                  <a:srgbClr val="F1F5F9"/>
                 </a:solidFill>
               </a:rPr>
               <a:t>• Real Tree Validation: Checks every candidate path against the fetched repository tree.</a:t>
@@ -4554,7 +4554,7 @@
             <a:r>
               <a:rPr lang="en-US" sz="1200" dirty="0">
                 <a:solidFill>
-                  <a:srgbClr val="17152D"/>
+                  <a:srgbClr val="F1F5F9"/>
                 </a:solidFill>
               </a:rPr>
               <a:t>• Hallucination Rejection: Nonexistent paths and hallucinated source IDs are demoted to UNKNOWN and logged in the audit ledger.</a:t>
@@ -4580,7 +4580,7 @@
             <a:r>
               <a:rPr lang="en-US" sz="1200" dirty="0">
                 <a:solidFill>
-                  <a:srgbClr val="17152D"/>
+                  <a:srgbClr val="F1F5F9"/>
                 </a:solidFill>
               </a:rPr>
               <a:t>• Safe Missing-Key Fallback: If GEMMA_API_KEY is absent, the deterministic baseline compiler activates. Zero broken screens or dummy results.</a:t>
@@ -4606,7 +4606,7 @@
             <a:r>
               <a:rPr lang="en-US" sz="1200" dirty="0">
                 <a:solidFill>
-                  <a:srgbClr val="17152D"/>
+                  <a:srgbClr val="F1F5F9"/>
                 </a:solidFill>
               </a:rPr>
               <a:t>• Zero Code Execution: Never runs repository scripts, never executes scanned code on server.</a:t>
@@ -4629,7 +4629,7 @@
     <p:bg>
       <p:bgPr>
         <a:solidFill>
-          <a:srgbClr val="F7F6FF"/>
+          <a:srgbClr val="0B1020"/>
         </a:solidFill>
       </p:bgPr>
     </p:bg>
@@ -4674,7 +4674,7 @@
             <a:r>
               <a:rPr lang="en-US" sz="1200" b="1" dirty="0">
                 <a:solidFill>
-                  <a:srgbClr val="7057F5"/>
+                  <a:srgbClr val="A78BFA"/>
                 </a:solidFill>
                 <a:latin typeface="Arial" pitchFamily="34" charset="0"/>
                 <a:ea typeface="Arial" pitchFamily="34" charset="-122"/>
@@ -4713,7 +4713,7 @@
             <a:r>
               <a:rPr lang="en-US" sz="2600" b="1" dirty="0">
                 <a:solidFill>
-                  <a:srgbClr val="17152D"/>
+                  <a:srgbClr val="F1F5F9"/>
                 </a:solidFill>
                 <a:latin typeface="Arial" pitchFamily="34" charset="0"/>
                 <a:ea typeface="Arial" pitchFamily="34" charset="-122"/>
@@ -6879,7 +6879,7 @@
     <p:bg>
       <p:bgPr>
         <a:solidFill>
-          <a:srgbClr val="F7F6FF"/>
+          <a:srgbClr val="0B1020"/>
         </a:solidFill>
       </p:bgPr>
     </p:bg>
@@ -6924,7 +6924,7 @@
             <a:r>
               <a:rPr lang="en-US" sz="1200" b="1" dirty="0">
                 <a:solidFill>
-                  <a:srgbClr val="7057F5"/>
+                  <a:srgbClr val="A78BFA"/>
                 </a:solidFill>
                 <a:latin typeface="Arial" pitchFamily="34" charset="0"/>
                 <a:ea typeface="Arial" pitchFamily="34" charset="-122"/>
@@ -6963,7 +6963,7 @@
             <a:r>
               <a:rPr lang="en-US" sz="2800" b="1" dirty="0">
                 <a:solidFill>
-                  <a:srgbClr val="17152D"/>
+                  <a:srgbClr val="F1F5F9"/>
                 </a:solidFill>
                 <a:latin typeface="Arial" pitchFamily="34" charset="0"/>
                 <a:ea typeface="Arial" pitchFamily="34" charset="-122"/>
@@ -6994,7 +6994,7 @@
           </a:solidFill>
           <a:ln w="25400">
             <a:solidFill>
-              <a:srgbClr val="7057F5"/>
+              <a:srgbClr val="A78BFA"/>
             </a:solidFill>
             <a:prstDash val="solid"/>
           </a:ln>
@@ -7030,7 +7030,7 @@
             <a:r>
               <a:rPr lang="en-US" sz="1500" i="1" dirty="0">
                 <a:solidFill>
-                  <a:srgbClr val="17152D"/>
+                  <a:srgbClr val="F1F5F9"/>
                 </a:solidFill>
               </a:rPr>
               <a:t>"IssueLift turns an open issue into a reviewable Contribution Contract and evidence-to-test map before coding begins. The deterministic Claim Gate can be inspected and improved; the public ProofBench lets contributors add counterexamples whenever a path, citation, requirement or test-evidence label is wrong. This makes reliability rules—not only UI code—open to community inspection and extension. We claim no impact numbers until measured."</a:t>
@@ -7066,7 +7066,7 @@
             <a:r>
               <a:rPr lang="en-US" sz="1300" b="1" dirty="0">
                 <a:solidFill>
-                  <a:srgbClr val="7057F5"/>
+                  <a:srgbClr val="A78BFA"/>
                 </a:solidFill>
               </a:rPr>
               <a:t>COMMUNITY PARTICIPATION WITHOUT TOUCHING MODEL WEIGHTS</a:t>
@@ -7105,7 +7105,7 @@
             <a:r>
               <a:rPr lang="en-US" sz="1200" dirty="0">
                 <a:solidFill>
-                  <a:srgbClr val="17152D"/>
+                  <a:srgbClr val="F1F5F9"/>
                 </a:solidFill>
               </a:rPr>
               <a:t>1. Inspectable Reliability: Proprietary AI tools hide reasoning failures behind opaque confidence scores. IssueLift makes every invariant inspectable in public fixtures.</a:t>
@@ -7131,7 +7131,7 @@
             <a:r>
               <a:rPr lang="en-US" sz="1200" dirty="0">
                 <a:solidFill>
-                  <a:srgbClr val="17152D"/>
+                  <a:srgbClr val="F1F5F9"/>
                 </a:solidFill>
               </a:rPr>
               <a:t>2. Community Counterexamples: A newcomer who finds a hallucinated path or mislabeled test file can submit a fixture in eval/fixtures/ without retraining an LLM.</a:t>
@@ -7157,7 +7157,7 @@
             <a:r>
               <a:rPr lang="en-US" sz="1200" dirty="0">
                 <a:solidFill>
-                  <a:srgbClr val="17152D"/>
+                  <a:srgbClr val="F1F5F9"/>
                 </a:solidFill>
               </a:rPr>
               <a:t>3. Sustainable Maintainer Health: Instead of flooding repositories with automated PR spam, open innovation here means higher signal: questions asked early, tests identified first.</a:t>
@@ -7180,7 +7180,7 @@
     <p:bg>
       <p:bgPr>
         <a:solidFill>
-          <a:srgbClr val="F7F6FF"/>
+          <a:srgbClr val="0B1020"/>
         </a:solidFill>
       </p:bgPr>
     </p:bg>
@@ -7225,7 +7225,7 @@
             <a:r>
               <a:rPr lang="en-US" sz="1200" b="1" dirty="0">
                 <a:solidFill>
-                  <a:srgbClr val="7057F5"/>
+                  <a:srgbClr val="A78BFA"/>
                 </a:solidFill>
                 <a:latin typeface="Arial" pitchFamily="34" charset="0"/>
                 <a:ea typeface="Arial" pitchFamily="34" charset="-122"/>
@@ -7264,7 +7264,7 @@
             <a:r>
               <a:rPr lang="en-US" sz="2600" b="1" dirty="0">
                 <a:solidFill>
-                  <a:srgbClr val="17152D"/>
+                  <a:srgbClr val="F1F5F9"/>
                 </a:solidFill>
                 <a:latin typeface="Arial" pitchFamily="34" charset="0"/>
                 <a:ea typeface="Arial" pitchFamily="34" charset="-122"/>

</xml_diff>

<commit_message>
refactor: replace prompt pack pdfs and text mirror with generated slide deck and build script
</commit_message>
<xml_diff>
--- a/submission/IssueLift_Submission.pptx
+++ b/submission/IssueLift_Submission.pptx
@@ -1858,8 +1858,8 @@
         </p:nvSpPr>
         <p:spPr>
           <a:xfrm>
-            <a:off x="731520" y="457200"/>
-            <a:ext cx="10515600" cy="274320"/>
+            <a:off x="658368" y="393192"/>
+            <a:ext cx="5486400" cy="256032"/>
           </a:xfrm>
           <a:prstGeom prst="rect">
             <a:avLst/>
@@ -1883,7 +1883,7 @@
                 <a:ea typeface="Arial" pitchFamily="34" charset="-122"/>
                 <a:cs typeface="Arial" pitchFamily="34" charset="-120"/>
               </a:rPr>
-              <a:t>MARKET SNAPSHOT &amp; POSITIONING</a:t>
+              <a:t>THE ISSUE LIFT WORKFLOW</a:t>
             </a:r>
             <a:endParaRPr lang="en-US" sz="1200" dirty="0"/>
           </a:p>
@@ -1897,8 +1897,8 @@
         </p:nvSpPr>
         <p:spPr>
           <a:xfrm>
-            <a:off x="731520" y="822960"/>
-            <a:ext cx="10515600" cy="548640"/>
+            <a:off x="658368" y="731520"/>
+            <a:ext cx="10881360" cy="530352"/>
           </a:xfrm>
           <a:prstGeom prst="rect">
             <a:avLst/>
@@ -1914,7 +1914,7 @@
               <a:buNone/>
             </a:pPr>
             <a:r>
-              <a:rPr lang="en-US" sz="2600" b="1" dirty="0">
+              <a:rPr lang="en-US" sz="2800" b="1" dirty="0">
                 <a:solidFill>
                   <a:srgbClr val="F1F5F9"/>
                 </a:solidFill>
@@ -1922,1414 +1922,1348 @@
                 <a:ea typeface="Arial" pitchFamily="34" charset="-122"/>
                 <a:cs typeface="Arial" pitchFamily="34" charset="-120"/>
               </a:rPr>
-              <a:t>Adjacent Categories vs. IssueLift Pre-Edit Contract</a:t>
+              <a:t>How IssueLift works before coding</a:t>
             </a:r>
-            <a:endParaRPr lang="en-US" sz="2600" dirty="0"/>
+            <a:endParaRPr lang="en-US" sz="2800" dirty="0"/>
           </a:p>
         </p:txBody>
       </p:sp>
-      <p:graphicFrame>
-        <p:nvGraphicFramePr>
-          <p:cNvPr id="3" name="Table 0"/>
-          <p:cNvGraphicFramePr>
-            <a:graphicFrameLocks noGrp="1"/>
-          </p:cNvGraphicFramePr>
-          <p:nvPr>
-            <p:extLst>
-              <p:ext uri="{D42A27DB-BD31-4B8C-83A1-F6EECF244321}">
-                <p14:modId xmlns:p14="http://schemas.microsoft.com/office/powerpoint/2010/main" val="1579011935"/>
-              </p:ext>
-            </p:extLst>
-          </p:nvPr>
-        </p:nvGraphicFramePr>
-        <p:xfrm>
-          <a:off x="731520" y="1554480"/>
-          <a:ext cx="10698480" cy="4572000"/>
-        </p:xfrm>
-        <a:graphic>
-          <a:graphicData uri="http://schemas.openxmlformats.org/drawingml/2006/table">
-            <a:tbl>
-              <a:tblPr/>
-              <a:tblGrid>
-                <a:gridCol w="2674620"/>
-                <a:gridCol w="2674620"/>
-                <a:gridCol w="2674620"/>
-                <a:gridCol w="2674620"/>
-              </a:tblGrid>
-              <a:tr h="914400">
-                <a:tc>
-                  <a:txBody>
-                    <a:bodyPr/>
-                    <a:lstStyle/>
-                    <a:p>
-                      <a:pPr indent="0" marL="0">
-                        <a:buNone/>
-                      </a:pPr>
-                      <a:r>
-                        <a:rPr lang="en-US" sz="1100" b="1" dirty="0">
-                          <a:solidFill>
-                            <a:srgbClr val="FFFFFF"/>
-                          </a:solidFill>
-                          <a:latin typeface="Arial" pitchFamily="34" charset="0"/>
-                          <a:ea typeface="Arial" pitchFamily="34" charset="-122"/>
-                          <a:cs typeface="Arial" pitchFamily="34" charset="-120"/>
-                        </a:rPr>
-                        <a:t>Tool / Category</a:t>
-                      </a:r>
-                      <a:endParaRPr lang="en-US" sz="1100" dirty="0">
-                        <a:latin typeface="Arial" charset="0"/>
-                        <a:ea typeface="Arial" charset="0"/>
-                        <a:cs typeface="Arial" charset="0"/>
-                      </a:endParaRPr>
-                    </a:p>
-                  </a:txBody>
-                  <a:tcPr marL="91440" marR="91440" marT="45720" marB="45720">
-                    <a:lnL w="12700" cap="flat" cmpd="sng" algn="ctr">
-                      <a:solidFill>
-                        <a:srgbClr val="232F48"/>
-                      </a:solidFill>
-                      <a:prstDash val="solid"/>
-                      <a:round/>
-                      <a:headEnd type="none" w="med" len="med"/>
-                      <a:tailEnd type="none" w="med" len="med"/>
-                    </a:lnL>
-                    <a:lnR w="12700" cap="flat" cmpd="sng" algn="ctr">
-                      <a:solidFill>
-                        <a:srgbClr val="232F48"/>
-                      </a:solidFill>
-                      <a:prstDash val="solid"/>
-                      <a:round/>
-                      <a:headEnd type="none" w="med" len="med"/>
-                      <a:tailEnd type="none" w="med" len="med"/>
-                    </a:lnR>
-                    <a:lnT w="12700" cap="flat" cmpd="sng" algn="ctr">
-                      <a:solidFill>
-                        <a:srgbClr val="232F48"/>
-                      </a:solidFill>
-                      <a:prstDash val="solid"/>
-                      <a:round/>
-                      <a:headEnd type="none" w="med" len="med"/>
-                      <a:tailEnd type="none" w="med" len="med"/>
-                    </a:lnT>
-                    <a:lnB w="12700" cap="flat" cmpd="sng" algn="ctr">
-                      <a:solidFill>
-                        <a:srgbClr val="232F48"/>
-                      </a:solidFill>
-                      <a:prstDash val="solid"/>
-                      <a:round/>
-                      <a:headEnd type="none" w="med" len="med"/>
-                      <a:tailEnd type="none" w="med" len="med"/>
-                    </a:lnB>
-                    <a:solidFill>
-                      <a:srgbClr val="1E293B"/>
-                    </a:solidFill>
-                  </a:tcPr>
-                </a:tc>
-                <a:tc>
-                  <a:txBody>
-                    <a:bodyPr/>
-                    <a:lstStyle/>
-                    <a:p>
-                      <a:pPr indent="0" marL="0">
-                        <a:buNone/>
-                      </a:pPr>
-                      <a:r>
-                        <a:rPr lang="en-US" sz="1100" b="1" dirty="0">
-                          <a:solidFill>
-                            <a:srgbClr val="FFFFFF"/>
-                          </a:solidFill>
-                          <a:latin typeface="Arial" pitchFamily="34" charset="0"/>
-                          <a:ea typeface="Arial" pitchFamily="34" charset="-122"/>
-                          <a:cs typeface="Arial" pitchFamily="34" charset="-120"/>
-                        </a:rPr>
-                        <a:t>What It Does Well</a:t>
-                      </a:r>
-                      <a:endParaRPr lang="en-US" sz="1100" dirty="0">
-                        <a:latin typeface="Arial" charset="0"/>
-                        <a:ea typeface="Arial" charset="0"/>
-                        <a:cs typeface="Arial" charset="0"/>
-                      </a:endParaRPr>
-                    </a:p>
-                  </a:txBody>
-                  <a:tcPr marL="91440" marR="91440" marT="45720" marB="45720">
-                    <a:lnL w="12700" cap="flat" cmpd="sng" algn="ctr">
-                      <a:solidFill>
-                        <a:srgbClr val="232F48"/>
-                      </a:solidFill>
-                      <a:prstDash val="solid"/>
-                      <a:round/>
-                      <a:headEnd type="none" w="med" len="med"/>
-                      <a:tailEnd type="none" w="med" len="med"/>
-                    </a:lnL>
-                    <a:lnR w="12700" cap="flat" cmpd="sng" algn="ctr">
-                      <a:solidFill>
-                        <a:srgbClr val="232F48"/>
-                      </a:solidFill>
-                      <a:prstDash val="solid"/>
-                      <a:round/>
-                      <a:headEnd type="none" w="med" len="med"/>
-                      <a:tailEnd type="none" w="med" len="med"/>
-                    </a:lnR>
-                    <a:lnT w="12700" cap="flat" cmpd="sng" algn="ctr">
-                      <a:solidFill>
-                        <a:srgbClr val="232F48"/>
-                      </a:solidFill>
-                      <a:prstDash val="solid"/>
-                      <a:round/>
-                      <a:headEnd type="none" w="med" len="med"/>
-                      <a:tailEnd type="none" w="med" len="med"/>
-                    </a:lnT>
-                    <a:lnB w="12700" cap="flat" cmpd="sng" algn="ctr">
-                      <a:solidFill>
-                        <a:srgbClr val="232F48"/>
-                      </a:solidFill>
-                      <a:prstDash val="solid"/>
-                      <a:round/>
-                      <a:headEnd type="none" w="med" len="med"/>
-                      <a:tailEnd type="none" w="med" len="med"/>
-                    </a:lnB>
-                    <a:solidFill>
-                      <a:srgbClr val="1E293B"/>
-                    </a:solidFill>
-                  </a:tcPr>
-                </a:tc>
-                <a:tc>
-                  <a:txBody>
-                    <a:bodyPr/>
-                    <a:lstStyle/>
-                    <a:p>
-                      <a:pPr indent="0" marL="0">
-                        <a:buNone/>
-                      </a:pPr>
-                      <a:r>
-                        <a:rPr lang="en-US" sz="1100" b="1" dirty="0">
-                          <a:solidFill>
-                            <a:srgbClr val="FFFFFF"/>
-                          </a:solidFill>
-                          <a:latin typeface="Arial" pitchFamily="34" charset="0"/>
-                          <a:ea typeface="Arial" pitchFamily="34" charset="-122"/>
-                          <a:cs typeface="Arial" pitchFamily="34" charset="-120"/>
-                        </a:rPr>
-                        <a:t>What IssueLift Does NOT Copy</a:t>
-                      </a:r>
-                      <a:endParaRPr lang="en-US" sz="1100" dirty="0">
-                        <a:latin typeface="Arial" charset="0"/>
-                        <a:ea typeface="Arial" charset="0"/>
-                        <a:cs typeface="Arial" charset="0"/>
-                      </a:endParaRPr>
-                    </a:p>
-                  </a:txBody>
-                  <a:tcPr marL="91440" marR="91440" marT="45720" marB="45720">
-                    <a:lnL w="12700" cap="flat" cmpd="sng" algn="ctr">
-                      <a:solidFill>
-                        <a:srgbClr val="232F48"/>
-                      </a:solidFill>
-                      <a:prstDash val="solid"/>
-                      <a:round/>
-                      <a:headEnd type="none" w="med" len="med"/>
-                      <a:tailEnd type="none" w="med" len="med"/>
-                    </a:lnL>
-                    <a:lnR w="12700" cap="flat" cmpd="sng" algn="ctr">
-                      <a:solidFill>
-                        <a:srgbClr val="232F48"/>
-                      </a:solidFill>
-                      <a:prstDash val="solid"/>
-                      <a:round/>
-                      <a:headEnd type="none" w="med" len="med"/>
-                      <a:tailEnd type="none" w="med" len="med"/>
-                    </a:lnR>
-                    <a:lnT w="12700" cap="flat" cmpd="sng" algn="ctr">
-                      <a:solidFill>
-                        <a:srgbClr val="232F48"/>
-                      </a:solidFill>
-                      <a:prstDash val="solid"/>
-                      <a:round/>
-                      <a:headEnd type="none" w="med" len="med"/>
-                      <a:tailEnd type="none" w="med" len="med"/>
-                    </a:lnT>
-                    <a:lnB w="12700" cap="flat" cmpd="sng" algn="ctr">
-                      <a:solidFill>
-                        <a:srgbClr val="232F48"/>
-                      </a:solidFill>
-                      <a:prstDash val="solid"/>
-                      <a:round/>
-                      <a:headEnd type="none" w="med" len="med"/>
-                      <a:tailEnd type="none" w="med" len="med"/>
-                    </a:lnB>
-                    <a:solidFill>
-                      <a:srgbClr val="1E293B"/>
-                    </a:solidFill>
-                  </a:tcPr>
-                </a:tc>
-                <a:tc>
-                  <a:txBody>
-                    <a:bodyPr/>
-                    <a:lstStyle/>
-                    <a:p>
-                      <a:pPr indent="0" marL="0">
-                        <a:buNone/>
-                      </a:pPr>
-                      <a:r>
-                        <a:rPr lang="en-US" sz="1100" b="1" dirty="0">
-                          <a:solidFill>
-                            <a:srgbClr val="FFFFFF"/>
-                          </a:solidFill>
-                          <a:latin typeface="Arial" pitchFamily="34" charset="0"/>
-                          <a:ea typeface="Arial" pitchFamily="34" charset="-122"/>
-                          <a:cs typeface="Arial" pitchFamily="34" charset="-120"/>
-                        </a:rPr>
-                        <a:t>IssueLift Differentiation</a:t>
-                      </a:r>
-                      <a:endParaRPr lang="en-US" sz="1100" dirty="0">
-                        <a:latin typeface="Arial" charset="0"/>
-                        <a:ea typeface="Arial" charset="0"/>
-                        <a:cs typeface="Arial" charset="0"/>
-                      </a:endParaRPr>
-                    </a:p>
-                  </a:txBody>
-                  <a:tcPr marL="91440" marR="91440" marT="45720" marB="45720">
-                    <a:lnL w="12700" cap="flat" cmpd="sng" algn="ctr">
-                      <a:solidFill>
-                        <a:srgbClr val="232F48"/>
-                      </a:solidFill>
-                      <a:prstDash val="solid"/>
-                      <a:round/>
-                      <a:headEnd type="none" w="med" len="med"/>
-                      <a:tailEnd type="none" w="med" len="med"/>
-                    </a:lnL>
-                    <a:lnR w="12700" cap="flat" cmpd="sng" algn="ctr">
-                      <a:solidFill>
-                        <a:srgbClr val="232F48"/>
-                      </a:solidFill>
-                      <a:prstDash val="solid"/>
-                      <a:round/>
-                      <a:headEnd type="none" w="med" len="med"/>
-                      <a:tailEnd type="none" w="med" len="med"/>
-                    </a:lnR>
-                    <a:lnT w="12700" cap="flat" cmpd="sng" algn="ctr">
-                      <a:solidFill>
-                        <a:srgbClr val="232F48"/>
-                      </a:solidFill>
-                      <a:prstDash val="solid"/>
-                      <a:round/>
-                      <a:headEnd type="none" w="med" len="med"/>
-                      <a:tailEnd type="none" w="med" len="med"/>
-                    </a:lnT>
-                    <a:lnB w="12700" cap="flat" cmpd="sng" algn="ctr">
-                      <a:solidFill>
-                        <a:srgbClr val="232F48"/>
-                      </a:solidFill>
-                      <a:prstDash val="solid"/>
-                      <a:round/>
-                      <a:headEnd type="none" w="med" len="med"/>
-                      <a:tailEnd type="none" w="med" len="med"/>
-                    </a:lnB>
-                    <a:solidFill>
-                      <a:srgbClr val="1E293B"/>
-                    </a:solidFill>
-                  </a:tcPr>
-                </a:tc>
-              </a:tr>
-              <a:tr h="914400">
-                <a:tc>
-                  <a:txBody>
-                    <a:bodyPr/>
-                    <a:lstStyle/>
-                    <a:p>
-                      <a:pPr indent="0" marL="0">
-                        <a:buNone/>
-                      </a:pPr>
-                      <a:r>
-                        <a:rPr lang="en-US" sz="1100" b="1" dirty="0">
-                          <a:solidFill>
-                            <a:srgbClr val="F1F5F9"/>
-                          </a:solidFill>
-                          <a:latin typeface="Arial" pitchFamily="34" charset="0"/>
-                          <a:ea typeface="Arial" pitchFamily="34" charset="-122"/>
-                          <a:cs typeface="Arial" pitchFamily="34" charset="-120"/>
-                        </a:rPr>
-                        <a:t>GoodFirst / IssueScout</a:t>
-                      </a:r>
-                      <a:endParaRPr lang="en-US" sz="1100" dirty="0">
-                        <a:latin typeface="Arial" charset="0"/>
-                        <a:ea typeface="Arial" charset="0"/>
-                        <a:cs typeface="Arial" charset="0"/>
-                      </a:endParaRPr>
-                    </a:p>
-                  </a:txBody>
-                  <a:tcPr marL="91440" marR="91440" marT="45720" marB="45720">
-                    <a:lnL w="12700" cap="flat" cmpd="sng" algn="ctr">
-                      <a:solidFill>
-                        <a:srgbClr val="232F48"/>
-                      </a:solidFill>
-                      <a:prstDash val="solid"/>
-                      <a:round/>
-                      <a:headEnd type="none" w="med" len="med"/>
-                      <a:tailEnd type="none" w="med" len="med"/>
-                    </a:lnL>
-                    <a:lnR w="12700" cap="flat" cmpd="sng" algn="ctr">
-                      <a:solidFill>
-                        <a:srgbClr val="232F48"/>
-                      </a:solidFill>
-                      <a:prstDash val="solid"/>
-                      <a:round/>
-                      <a:headEnd type="none" w="med" len="med"/>
-                      <a:tailEnd type="none" w="med" len="med"/>
-                    </a:lnR>
-                    <a:lnT w="12700" cap="flat" cmpd="sng" algn="ctr">
-                      <a:solidFill>
-                        <a:srgbClr val="232F48"/>
-                      </a:solidFill>
-                      <a:prstDash val="solid"/>
-                      <a:round/>
-                      <a:headEnd type="none" w="med" len="med"/>
-                      <a:tailEnd type="none" w="med" len="med"/>
-                    </a:lnT>
-                    <a:lnB w="12700" cap="flat" cmpd="sng" algn="ctr">
-                      <a:solidFill>
-                        <a:srgbClr val="232F48"/>
-                      </a:solidFill>
-                      <a:prstDash val="solid"/>
-                      <a:round/>
-                      <a:headEnd type="none" w="med" len="med"/>
-                      <a:tailEnd type="none" w="med" len="med"/>
-                    </a:lnB>
-                    <a:solidFill>
-                      <a:srgbClr val="121A2B"/>
-                    </a:solidFill>
-                  </a:tcPr>
-                </a:tc>
-                <a:tc>
-                  <a:txBody>
-                    <a:bodyPr/>
-                    <a:lstStyle/>
-                    <a:p>
-                      <a:pPr indent="0" marL="0">
-                        <a:buNone/>
-                      </a:pPr>
-                      <a:r>
-                        <a:rPr lang="en-US" sz="1100" dirty="0">
-                          <a:solidFill>
-                            <a:srgbClr val="F1F5F9"/>
-                          </a:solidFill>
-                          <a:latin typeface="Arial" pitchFamily="34" charset="0"/>
-                          <a:ea typeface="Arial" pitchFamily="34" charset="-122"/>
-                          <a:cs typeface="Arial" pitchFamily="34" charset="-120"/>
-                        </a:rPr>
-                        <a:t>Issue discovery, beginner issue pickers, difficulty tags.</a:t>
-                      </a:r>
-                      <a:endParaRPr lang="en-US" sz="1100" dirty="0">
-                        <a:latin typeface="Arial" charset="0"/>
-                        <a:ea typeface="Arial" charset="0"/>
-                        <a:cs typeface="Arial" charset="0"/>
-                      </a:endParaRPr>
-                    </a:p>
-                  </a:txBody>
-                  <a:tcPr marL="91440" marR="91440" marT="45720" marB="45720">
-                    <a:lnL w="12700" cap="flat" cmpd="sng" algn="ctr">
-                      <a:solidFill>
-                        <a:srgbClr val="232F48"/>
-                      </a:solidFill>
-                      <a:prstDash val="solid"/>
-                      <a:round/>
-                      <a:headEnd type="none" w="med" len="med"/>
-                      <a:tailEnd type="none" w="med" len="med"/>
-                    </a:lnL>
-                    <a:lnR w="12700" cap="flat" cmpd="sng" algn="ctr">
-                      <a:solidFill>
-                        <a:srgbClr val="232F48"/>
-                      </a:solidFill>
-                      <a:prstDash val="solid"/>
-                      <a:round/>
-                      <a:headEnd type="none" w="med" len="med"/>
-                      <a:tailEnd type="none" w="med" len="med"/>
-                    </a:lnR>
-                    <a:lnT w="12700" cap="flat" cmpd="sng" algn="ctr">
-                      <a:solidFill>
-                        <a:srgbClr val="232F48"/>
-                      </a:solidFill>
-                      <a:prstDash val="solid"/>
-                      <a:round/>
-                      <a:headEnd type="none" w="med" len="med"/>
-                      <a:tailEnd type="none" w="med" len="med"/>
-                    </a:lnT>
-                    <a:lnB w="12700" cap="flat" cmpd="sng" algn="ctr">
-                      <a:solidFill>
-                        <a:srgbClr val="232F48"/>
-                      </a:solidFill>
-                      <a:prstDash val="solid"/>
-                      <a:round/>
-                      <a:headEnd type="none" w="med" len="med"/>
-                      <a:tailEnd type="none" w="med" len="med"/>
-                    </a:lnB>
-                    <a:solidFill>
-                      <a:srgbClr val="121A2B"/>
-                    </a:solidFill>
-                  </a:tcPr>
-                </a:tc>
-                <a:tc>
-                  <a:txBody>
-                    <a:bodyPr/>
-                    <a:lstStyle/>
-                    <a:p>
-                      <a:pPr indent="0" marL="0">
-                        <a:buNone/>
-                      </a:pPr>
-                      <a:r>
-                        <a:rPr lang="en-US" sz="1100" dirty="0">
-                          <a:solidFill>
-                            <a:srgbClr val="F1F5F9"/>
-                          </a:solidFill>
-                          <a:latin typeface="Arial" pitchFamily="34" charset="0"/>
-                          <a:ea typeface="Arial" pitchFamily="34" charset="-122"/>
-                          <a:cs typeface="Arial" pitchFamily="34" charset="-120"/>
-                        </a:rPr>
-                        <a:t>Do not build another issue directory or generic difficulty score.</a:t>
-                      </a:r>
-                      <a:endParaRPr lang="en-US" sz="1100" dirty="0">
-                        <a:latin typeface="Arial" charset="0"/>
-                        <a:ea typeface="Arial" charset="0"/>
-                        <a:cs typeface="Arial" charset="0"/>
-                      </a:endParaRPr>
-                    </a:p>
-                  </a:txBody>
-                  <a:tcPr marL="91440" marR="91440" marT="45720" marB="45720">
-                    <a:lnL w="12700" cap="flat" cmpd="sng" algn="ctr">
-                      <a:solidFill>
-                        <a:srgbClr val="232F48"/>
-                      </a:solidFill>
-                      <a:prstDash val="solid"/>
-                      <a:round/>
-                      <a:headEnd type="none" w="med" len="med"/>
-                      <a:tailEnd type="none" w="med" len="med"/>
-                    </a:lnL>
-                    <a:lnR w="12700" cap="flat" cmpd="sng" algn="ctr">
-                      <a:solidFill>
-                        <a:srgbClr val="232F48"/>
-                      </a:solidFill>
-                      <a:prstDash val="solid"/>
-                      <a:round/>
-                      <a:headEnd type="none" w="med" len="med"/>
-                      <a:tailEnd type="none" w="med" len="med"/>
-                    </a:lnR>
-                    <a:lnT w="12700" cap="flat" cmpd="sng" algn="ctr">
-                      <a:solidFill>
-                        <a:srgbClr val="232F48"/>
-                      </a:solidFill>
-                      <a:prstDash val="solid"/>
-                      <a:round/>
-                      <a:headEnd type="none" w="med" len="med"/>
-                      <a:tailEnd type="none" w="med" len="med"/>
-                    </a:lnT>
-                    <a:lnB w="12700" cap="flat" cmpd="sng" algn="ctr">
-                      <a:solidFill>
-                        <a:srgbClr val="232F48"/>
-                      </a:solidFill>
-                      <a:prstDash val="solid"/>
-                      <a:round/>
-                      <a:headEnd type="none" w="med" len="med"/>
-                      <a:tailEnd type="none" w="med" len="med"/>
-                    </a:lnB>
-                    <a:solidFill>
-                      <a:srgbClr val="121A2B"/>
-                    </a:solidFill>
-                  </a:tcPr>
-                </a:tc>
-                <a:tc>
-                  <a:txBody>
-                    <a:bodyPr/>
-                    <a:lstStyle/>
-                    <a:p>
-                      <a:pPr indent="0" marL="0">
-                        <a:buNone/>
-                      </a:pPr>
-                      <a:r>
-                        <a:rPr lang="en-US" sz="1100" dirty="0">
-                          <a:solidFill>
-                            <a:srgbClr val="F1F5F9"/>
-                          </a:solidFill>
-                          <a:latin typeface="Arial" pitchFamily="34" charset="0"/>
-                          <a:ea typeface="Arial" pitchFamily="34" charset="-122"/>
-                          <a:cs typeface="Arial" pitchFamily="34" charset="-120"/>
-                        </a:rPr>
-                        <a:t>Starts AFTER the issue is picked; defines contract before code edits.</a:t>
-                      </a:r>
-                      <a:endParaRPr lang="en-US" sz="1100" dirty="0">
-                        <a:latin typeface="Arial" charset="0"/>
-                        <a:ea typeface="Arial" charset="0"/>
-                        <a:cs typeface="Arial" charset="0"/>
-                      </a:endParaRPr>
-                    </a:p>
-                  </a:txBody>
-                  <a:tcPr marL="91440" marR="91440" marT="45720" marB="45720">
-                    <a:lnL w="12700" cap="flat" cmpd="sng" algn="ctr">
-                      <a:solidFill>
-                        <a:srgbClr val="232F48"/>
-                      </a:solidFill>
-                      <a:prstDash val="solid"/>
-                      <a:round/>
-                      <a:headEnd type="none" w="med" len="med"/>
-                      <a:tailEnd type="none" w="med" len="med"/>
-                    </a:lnL>
-                    <a:lnR w="12700" cap="flat" cmpd="sng" algn="ctr">
-                      <a:solidFill>
-                        <a:srgbClr val="232F48"/>
-                      </a:solidFill>
-                      <a:prstDash val="solid"/>
-                      <a:round/>
-                      <a:headEnd type="none" w="med" len="med"/>
-                      <a:tailEnd type="none" w="med" len="med"/>
-                    </a:lnR>
-                    <a:lnT w="12700" cap="flat" cmpd="sng" algn="ctr">
-                      <a:solidFill>
-                        <a:srgbClr val="232F48"/>
-                      </a:solidFill>
-                      <a:prstDash val="solid"/>
-                      <a:round/>
-                      <a:headEnd type="none" w="med" len="med"/>
-                      <a:tailEnd type="none" w="med" len="med"/>
-                    </a:lnT>
-                    <a:lnB w="12700" cap="flat" cmpd="sng" algn="ctr">
-                      <a:solidFill>
-                        <a:srgbClr val="232F48"/>
-                      </a:solidFill>
-                      <a:prstDash val="solid"/>
-                      <a:round/>
-                      <a:headEnd type="none" w="med" len="med"/>
-                      <a:tailEnd type="none" w="med" len="med"/>
-                    </a:lnB>
-                    <a:solidFill>
-                      <a:srgbClr val="121A2B"/>
-                    </a:solidFill>
-                  </a:tcPr>
-                </a:tc>
-              </a:tr>
-              <a:tr h="914400">
-                <a:tc>
-                  <a:txBody>
-                    <a:bodyPr/>
-                    <a:lstStyle/>
-                    <a:p>
-                      <a:pPr indent="0" marL="0">
-                        <a:buNone/>
-                      </a:pPr>
-                      <a:r>
-                        <a:rPr lang="en-US" sz="1100" b="1" dirty="0">
-                          <a:solidFill>
-                            <a:srgbClr val="F1F5F9"/>
-                          </a:solidFill>
-                          <a:latin typeface="Arial" pitchFamily="34" charset="0"/>
-                          <a:ea typeface="Arial" pitchFamily="34" charset="-122"/>
-                          <a:cs typeface="Arial" pitchFamily="34" charset="-120"/>
-                        </a:rPr>
-                        <a:t>Ossistant</a:t>
-                      </a:r>
-                      <a:endParaRPr lang="en-US" sz="1100" dirty="0">
-                        <a:latin typeface="Arial" charset="0"/>
-                        <a:ea typeface="Arial" charset="0"/>
-                        <a:cs typeface="Arial" charset="0"/>
-                      </a:endParaRPr>
-                    </a:p>
-                  </a:txBody>
-                  <a:tcPr marL="91440" marR="91440" marT="45720" marB="45720">
-                    <a:lnL w="12700" cap="flat" cmpd="sng" algn="ctr">
-                      <a:solidFill>
-                        <a:srgbClr val="232F48"/>
-                      </a:solidFill>
-                      <a:prstDash val="solid"/>
-                      <a:round/>
-                      <a:headEnd type="none" w="med" len="med"/>
-                      <a:tailEnd type="none" w="med" len="med"/>
-                    </a:lnL>
-                    <a:lnR w="12700" cap="flat" cmpd="sng" algn="ctr">
-                      <a:solidFill>
-                        <a:srgbClr val="232F48"/>
-                      </a:solidFill>
-                      <a:prstDash val="solid"/>
-                      <a:round/>
-                      <a:headEnd type="none" w="med" len="med"/>
-                      <a:tailEnd type="none" w="med" len="med"/>
-                    </a:lnR>
-                    <a:lnT w="12700" cap="flat" cmpd="sng" algn="ctr">
-                      <a:solidFill>
-                        <a:srgbClr val="232F48"/>
-                      </a:solidFill>
-                      <a:prstDash val="solid"/>
-                      <a:round/>
-                      <a:headEnd type="none" w="med" len="med"/>
-                      <a:tailEnd type="none" w="med" len="med"/>
-                    </a:lnT>
-                    <a:lnB w="12700" cap="flat" cmpd="sng" algn="ctr">
-                      <a:solidFill>
-                        <a:srgbClr val="232F48"/>
-                      </a:solidFill>
-                      <a:prstDash val="solid"/>
-                      <a:round/>
-                      <a:headEnd type="none" w="med" len="med"/>
-                      <a:tailEnd type="none" w="med" len="med"/>
-                    </a:lnB>
-                    <a:solidFill>
-                      <a:srgbClr val="121A2B"/>
-                    </a:solidFill>
-                  </a:tcPr>
-                </a:tc>
-                <a:tc>
-                  <a:txBody>
-                    <a:bodyPr/>
-                    <a:lstStyle/>
-                    <a:p>
-                      <a:pPr indent="0" marL="0">
-                        <a:buNone/>
-                      </a:pPr>
-                      <a:r>
-                        <a:rPr lang="en-US" sz="1100" dirty="0">
-                          <a:solidFill>
-                            <a:srgbClr val="F1F5F9"/>
-                          </a:solidFill>
-                          <a:latin typeface="Arial" pitchFamily="34" charset="0"/>
-                          <a:ea typeface="Arial" pitchFamily="34" charset="-122"/>
-                          <a:cs typeface="Arial" pitchFamily="34" charset="-120"/>
-                        </a:rPr>
-                        <a:t>Repo chatbot, general explanation of open source programs.</a:t>
-                      </a:r>
-                      <a:endParaRPr lang="en-US" sz="1100" dirty="0">
-                        <a:latin typeface="Arial" charset="0"/>
-                        <a:ea typeface="Arial" charset="0"/>
-                        <a:cs typeface="Arial" charset="0"/>
-                      </a:endParaRPr>
-                    </a:p>
-                  </a:txBody>
-                  <a:tcPr marL="91440" marR="91440" marT="45720" marB="45720">
-                    <a:lnL w="12700" cap="flat" cmpd="sng" algn="ctr">
-                      <a:solidFill>
-                        <a:srgbClr val="232F48"/>
-                      </a:solidFill>
-                      <a:prstDash val="solid"/>
-                      <a:round/>
-                      <a:headEnd type="none" w="med" len="med"/>
-                      <a:tailEnd type="none" w="med" len="med"/>
-                    </a:lnL>
-                    <a:lnR w="12700" cap="flat" cmpd="sng" algn="ctr">
-                      <a:solidFill>
-                        <a:srgbClr val="232F48"/>
-                      </a:solidFill>
-                      <a:prstDash val="solid"/>
-                      <a:round/>
-                      <a:headEnd type="none" w="med" len="med"/>
-                      <a:tailEnd type="none" w="med" len="med"/>
-                    </a:lnR>
-                    <a:lnT w="12700" cap="flat" cmpd="sng" algn="ctr">
-                      <a:solidFill>
-                        <a:srgbClr val="232F48"/>
-                      </a:solidFill>
-                      <a:prstDash val="solid"/>
-                      <a:round/>
-                      <a:headEnd type="none" w="med" len="med"/>
-                      <a:tailEnd type="none" w="med" len="med"/>
-                    </a:lnT>
-                    <a:lnB w="12700" cap="flat" cmpd="sng" algn="ctr">
-                      <a:solidFill>
-                        <a:srgbClr val="232F48"/>
-                      </a:solidFill>
-                      <a:prstDash val="solid"/>
-                      <a:round/>
-                      <a:headEnd type="none" w="med" len="med"/>
-                      <a:tailEnd type="none" w="med" len="med"/>
-                    </a:lnB>
-                    <a:solidFill>
-                      <a:srgbClr val="121A2B"/>
-                    </a:solidFill>
-                  </a:tcPr>
-                </a:tc>
-                <a:tc>
-                  <a:txBody>
-                    <a:bodyPr/>
-                    <a:lstStyle/>
-                    <a:p>
-                      <a:pPr indent="0" marL="0">
-                        <a:buNone/>
-                      </a:pPr>
-                      <a:r>
-                        <a:rPr lang="en-US" sz="1100" dirty="0">
-                          <a:solidFill>
-                            <a:srgbClr val="F1F5F9"/>
-                          </a:solidFill>
-                          <a:latin typeface="Arial" pitchFamily="34" charset="0"/>
-                          <a:ea typeface="Arial" pitchFamily="34" charset="-122"/>
-                          <a:cs typeface="Arial" pitchFamily="34" charset="-120"/>
-                        </a:rPr>
-                        <a:t>Do not build a conversational chat assistant.</a:t>
-                      </a:r>
-                      <a:endParaRPr lang="en-US" sz="1100" dirty="0">
-                        <a:latin typeface="Arial" charset="0"/>
-                        <a:ea typeface="Arial" charset="0"/>
-                        <a:cs typeface="Arial" charset="0"/>
-                      </a:endParaRPr>
-                    </a:p>
-                  </a:txBody>
-                  <a:tcPr marL="91440" marR="91440" marT="45720" marB="45720">
-                    <a:lnL w="12700" cap="flat" cmpd="sng" algn="ctr">
-                      <a:solidFill>
-                        <a:srgbClr val="232F48"/>
-                      </a:solidFill>
-                      <a:prstDash val="solid"/>
-                      <a:round/>
-                      <a:headEnd type="none" w="med" len="med"/>
-                      <a:tailEnd type="none" w="med" len="med"/>
-                    </a:lnL>
-                    <a:lnR w="12700" cap="flat" cmpd="sng" algn="ctr">
-                      <a:solidFill>
-                        <a:srgbClr val="232F48"/>
-                      </a:solidFill>
-                      <a:prstDash val="solid"/>
-                      <a:round/>
-                      <a:headEnd type="none" w="med" len="med"/>
-                      <a:tailEnd type="none" w="med" len="med"/>
-                    </a:lnR>
-                    <a:lnT w="12700" cap="flat" cmpd="sng" algn="ctr">
-                      <a:solidFill>
-                        <a:srgbClr val="232F48"/>
-                      </a:solidFill>
-                      <a:prstDash val="solid"/>
-                      <a:round/>
-                      <a:headEnd type="none" w="med" len="med"/>
-                      <a:tailEnd type="none" w="med" len="med"/>
-                    </a:lnT>
-                    <a:lnB w="12700" cap="flat" cmpd="sng" algn="ctr">
-                      <a:solidFill>
-                        <a:srgbClr val="232F48"/>
-                      </a:solidFill>
-                      <a:prstDash val="solid"/>
-                      <a:round/>
-                      <a:headEnd type="none" w="med" len="med"/>
-                      <a:tailEnd type="none" w="med" len="med"/>
-                    </a:lnB>
-                    <a:solidFill>
-                      <a:srgbClr val="121A2B"/>
-                    </a:solidFill>
-                  </a:tcPr>
-                </a:tc>
-                <a:tc>
-                  <a:txBody>
-                    <a:bodyPr/>
-                    <a:lstStyle/>
-                    <a:p>
-                      <a:pPr indent="0" marL="0">
-                        <a:buNone/>
-                      </a:pPr>
-                      <a:r>
-                        <a:rPr lang="en-US" sz="1100" dirty="0">
-                          <a:solidFill>
-                            <a:srgbClr val="F1F5F9"/>
-                          </a:solidFill>
-                          <a:latin typeface="Arial" pitchFamily="34" charset="0"/>
-                          <a:ea typeface="Arial" pitchFamily="34" charset="-122"/>
-                          <a:cs typeface="Arial" pitchFamily="34" charset="-120"/>
-                        </a:rPr>
-                        <a:t>Deterministic, structured, exportable Proof Bundle artifacts.</a:t>
-                      </a:r>
-                      <a:endParaRPr lang="en-US" sz="1100" dirty="0">
-                        <a:latin typeface="Arial" charset="0"/>
-                        <a:ea typeface="Arial" charset="0"/>
-                        <a:cs typeface="Arial" charset="0"/>
-                      </a:endParaRPr>
-                    </a:p>
-                  </a:txBody>
-                  <a:tcPr marL="91440" marR="91440" marT="45720" marB="45720">
-                    <a:lnL w="12700" cap="flat" cmpd="sng" algn="ctr">
-                      <a:solidFill>
-                        <a:srgbClr val="232F48"/>
-                      </a:solidFill>
-                      <a:prstDash val="solid"/>
-                      <a:round/>
-                      <a:headEnd type="none" w="med" len="med"/>
-                      <a:tailEnd type="none" w="med" len="med"/>
-                    </a:lnL>
-                    <a:lnR w="12700" cap="flat" cmpd="sng" algn="ctr">
-                      <a:solidFill>
-                        <a:srgbClr val="232F48"/>
-                      </a:solidFill>
-                      <a:prstDash val="solid"/>
-                      <a:round/>
-                      <a:headEnd type="none" w="med" len="med"/>
-                      <a:tailEnd type="none" w="med" len="med"/>
-                    </a:lnR>
-                    <a:lnT w="12700" cap="flat" cmpd="sng" algn="ctr">
-                      <a:solidFill>
-                        <a:srgbClr val="232F48"/>
-                      </a:solidFill>
-                      <a:prstDash val="solid"/>
-                      <a:round/>
-                      <a:headEnd type="none" w="med" len="med"/>
-                      <a:tailEnd type="none" w="med" len="med"/>
-                    </a:lnT>
-                    <a:lnB w="12700" cap="flat" cmpd="sng" algn="ctr">
-                      <a:solidFill>
-                        <a:srgbClr val="232F48"/>
-                      </a:solidFill>
-                      <a:prstDash val="solid"/>
-                      <a:round/>
-                      <a:headEnd type="none" w="med" len="med"/>
-                      <a:tailEnd type="none" w="med" len="med"/>
-                    </a:lnB>
-                    <a:solidFill>
-                      <a:srgbClr val="121A2B"/>
-                    </a:solidFill>
-                  </a:tcPr>
-                </a:tc>
-              </a:tr>
-              <a:tr h="914400">
-                <a:tc>
-                  <a:txBody>
-                    <a:bodyPr/>
-                    <a:lstStyle/>
-                    <a:p>
-                      <a:pPr indent="0" marL="0">
-                        <a:buNone/>
-                      </a:pPr>
-                      <a:r>
-                        <a:rPr lang="en-US" sz="1100" b="1" dirty="0">
-                          <a:solidFill>
-                            <a:srgbClr val="F1F5F9"/>
-                          </a:solidFill>
-                          <a:latin typeface="Arial" pitchFamily="34" charset="0"/>
-                          <a:ea typeface="Arial" pitchFamily="34" charset="-122"/>
-                          <a:cs typeface="Arial" pitchFamily="34" charset="-120"/>
-                        </a:rPr>
-                        <a:t>CodeRabbit</a:t>
-                      </a:r>
-                      <a:endParaRPr lang="en-US" sz="1100" dirty="0">
-                        <a:latin typeface="Arial" charset="0"/>
-                        <a:ea typeface="Arial" charset="0"/>
-                        <a:cs typeface="Arial" charset="0"/>
-                      </a:endParaRPr>
-                    </a:p>
-                  </a:txBody>
-                  <a:tcPr marL="91440" marR="91440" marT="45720" marB="45720">
-                    <a:lnL w="12700" cap="flat" cmpd="sng" algn="ctr">
-                      <a:solidFill>
-                        <a:srgbClr val="232F48"/>
-                      </a:solidFill>
-                      <a:prstDash val="solid"/>
-                      <a:round/>
-                      <a:headEnd type="none" w="med" len="med"/>
-                      <a:tailEnd type="none" w="med" len="med"/>
-                    </a:lnL>
-                    <a:lnR w="12700" cap="flat" cmpd="sng" algn="ctr">
-                      <a:solidFill>
-                        <a:srgbClr val="232F48"/>
-                      </a:solidFill>
-                      <a:prstDash val="solid"/>
-                      <a:round/>
-                      <a:headEnd type="none" w="med" len="med"/>
-                      <a:tailEnd type="none" w="med" len="med"/>
-                    </a:lnR>
-                    <a:lnT w="12700" cap="flat" cmpd="sng" algn="ctr">
-                      <a:solidFill>
-                        <a:srgbClr val="232F48"/>
-                      </a:solidFill>
-                      <a:prstDash val="solid"/>
-                      <a:round/>
-                      <a:headEnd type="none" w="med" len="med"/>
-                      <a:tailEnd type="none" w="med" len="med"/>
-                    </a:lnT>
-                    <a:lnB w="12700" cap="flat" cmpd="sng" algn="ctr">
-                      <a:solidFill>
-                        <a:srgbClr val="232F48"/>
-                      </a:solidFill>
-                      <a:prstDash val="solid"/>
-                      <a:round/>
-                      <a:headEnd type="none" w="med" len="med"/>
-                      <a:tailEnd type="none" w="med" len="med"/>
-                    </a:lnB>
-                    <a:solidFill>
-                      <a:srgbClr val="121A2B"/>
-                    </a:solidFill>
-                  </a:tcPr>
-                </a:tc>
-                <a:tc>
-                  <a:txBody>
-                    <a:bodyPr/>
-                    <a:lstStyle/>
-                    <a:p>
-                      <a:pPr indent="0" marL="0">
-                        <a:buNone/>
-                      </a:pPr>
-                      <a:r>
-                        <a:rPr lang="en-US" sz="1100" dirty="0">
-                          <a:solidFill>
-                            <a:srgbClr val="F1F5F9"/>
-                          </a:solidFill>
-                          <a:latin typeface="Arial" pitchFamily="34" charset="0"/>
-                          <a:ea typeface="Arial" pitchFamily="34" charset="-122"/>
-                          <a:cs typeface="Arial" pitchFamily="34" charset="-120"/>
-                        </a:rPr>
-                        <a:t>Automated post-PR code review and pre-merge checks.</a:t>
-                      </a:r>
-                      <a:endParaRPr lang="en-US" sz="1100" dirty="0">
-                        <a:latin typeface="Arial" charset="0"/>
-                        <a:ea typeface="Arial" charset="0"/>
-                        <a:cs typeface="Arial" charset="0"/>
-                      </a:endParaRPr>
-                    </a:p>
-                  </a:txBody>
-                  <a:tcPr marL="91440" marR="91440" marT="45720" marB="45720">
-                    <a:lnL w="12700" cap="flat" cmpd="sng" algn="ctr">
-                      <a:solidFill>
-                        <a:srgbClr val="232F48"/>
-                      </a:solidFill>
-                      <a:prstDash val="solid"/>
-                      <a:round/>
-                      <a:headEnd type="none" w="med" len="med"/>
-                      <a:tailEnd type="none" w="med" len="med"/>
-                    </a:lnL>
-                    <a:lnR w="12700" cap="flat" cmpd="sng" algn="ctr">
-                      <a:solidFill>
-                        <a:srgbClr val="232F48"/>
-                      </a:solidFill>
-                      <a:prstDash val="solid"/>
-                      <a:round/>
-                      <a:headEnd type="none" w="med" len="med"/>
-                      <a:tailEnd type="none" w="med" len="med"/>
-                    </a:lnR>
-                    <a:lnT w="12700" cap="flat" cmpd="sng" algn="ctr">
-                      <a:solidFill>
-                        <a:srgbClr val="232F48"/>
-                      </a:solidFill>
-                      <a:prstDash val="solid"/>
-                      <a:round/>
-                      <a:headEnd type="none" w="med" len="med"/>
-                      <a:tailEnd type="none" w="med" len="med"/>
-                    </a:lnT>
-                    <a:lnB w="12700" cap="flat" cmpd="sng" algn="ctr">
-                      <a:solidFill>
-                        <a:srgbClr val="232F48"/>
-                      </a:solidFill>
-                      <a:prstDash val="solid"/>
-                      <a:round/>
-                      <a:headEnd type="none" w="med" len="med"/>
-                      <a:tailEnd type="none" w="med" len="med"/>
-                    </a:lnB>
-                    <a:solidFill>
-                      <a:srgbClr val="121A2B"/>
-                    </a:solidFill>
-                  </a:tcPr>
-                </a:tc>
-                <a:tc>
-                  <a:txBody>
-                    <a:bodyPr/>
-                    <a:lstStyle/>
-                    <a:p>
-                      <a:pPr indent="0" marL="0">
-                        <a:buNone/>
-                      </a:pPr>
-                      <a:r>
-                        <a:rPr lang="en-US" sz="1100" dirty="0">
-                          <a:solidFill>
-                            <a:srgbClr val="F1F5F9"/>
-                          </a:solidFill>
-                          <a:latin typeface="Arial" pitchFamily="34" charset="0"/>
-                          <a:ea typeface="Arial" pitchFamily="34" charset="-122"/>
-                          <a:cs typeface="Arial" pitchFamily="34" charset="-120"/>
-                        </a:rPr>
-                        <a:t>Do not build post-PR code review.</a:t>
-                      </a:r>
-                      <a:endParaRPr lang="en-US" sz="1100" dirty="0">
-                        <a:latin typeface="Arial" charset="0"/>
-                        <a:ea typeface="Arial" charset="0"/>
-                        <a:cs typeface="Arial" charset="0"/>
-                      </a:endParaRPr>
-                    </a:p>
-                  </a:txBody>
-                  <a:tcPr marL="91440" marR="91440" marT="45720" marB="45720">
-                    <a:lnL w="12700" cap="flat" cmpd="sng" algn="ctr">
-                      <a:solidFill>
-                        <a:srgbClr val="232F48"/>
-                      </a:solidFill>
-                      <a:prstDash val="solid"/>
-                      <a:round/>
-                      <a:headEnd type="none" w="med" len="med"/>
-                      <a:tailEnd type="none" w="med" len="med"/>
-                    </a:lnL>
-                    <a:lnR w="12700" cap="flat" cmpd="sng" algn="ctr">
-                      <a:solidFill>
-                        <a:srgbClr val="232F48"/>
-                      </a:solidFill>
-                      <a:prstDash val="solid"/>
-                      <a:round/>
-                      <a:headEnd type="none" w="med" len="med"/>
-                      <a:tailEnd type="none" w="med" len="med"/>
-                    </a:lnR>
-                    <a:lnT w="12700" cap="flat" cmpd="sng" algn="ctr">
-                      <a:solidFill>
-                        <a:srgbClr val="232F48"/>
-                      </a:solidFill>
-                      <a:prstDash val="solid"/>
-                      <a:round/>
-                      <a:headEnd type="none" w="med" len="med"/>
-                      <a:tailEnd type="none" w="med" len="med"/>
-                    </a:lnT>
-                    <a:lnB w="12700" cap="flat" cmpd="sng" algn="ctr">
-                      <a:solidFill>
-                        <a:srgbClr val="232F48"/>
-                      </a:solidFill>
-                      <a:prstDash val="solid"/>
-                      <a:round/>
-                      <a:headEnd type="none" w="med" len="med"/>
-                      <a:tailEnd type="none" w="med" len="med"/>
-                    </a:lnB>
-                    <a:solidFill>
-                      <a:srgbClr val="121A2B"/>
-                    </a:solidFill>
-                  </a:tcPr>
-                </a:tc>
-                <a:tc>
-                  <a:txBody>
-                    <a:bodyPr/>
-                    <a:lstStyle/>
-                    <a:p>
-                      <a:pPr indent="0" marL="0">
-                        <a:buNone/>
-                      </a:pPr>
-                      <a:r>
-                        <a:rPr lang="en-US" sz="1100" dirty="0">
-                          <a:solidFill>
-                            <a:srgbClr val="F1F5F9"/>
-                          </a:solidFill>
-                          <a:latin typeface="Arial" pitchFamily="34" charset="0"/>
-                          <a:ea typeface="Arial" pitchFamily="34" charset="-122"/>
-                          <a:cs typeface="Arial" pitchFamily="34" charset="-120"/>
-                        </a:rPr>
-                        <a:t>Pre-PR clarification: align on "done" before submitting PRs.</a:t>
-                      </a:r>
-                      <a:endParaRPr lang="en-US" sz="1100" dirty="0">
-                        <a:latin typeface="Arial" charset="0"/>
-                        <a:ea typeface="Arial" charset="0"/>
-                        <a:cs typeface="Arial" charset="0"/>
-                      </a:endParaRPr>
-                    </a:p>
-                  </a:txBody>
-                  <a:tcPr marL="91440" marR="91440" marT="45720" marB="45720">
-                    <a:lnL w="12700" cap="flat" cmpd="sng" algn="ctr">
-                      <a:solidFill>
-                        <a:srgbClr val="232F48"/>
-                      </a:solidFill>
-                      <a:prstDash val="solid"/>
-                      <a:round/>
-                      <a:headEnd type="none" w="med" len="med"/>
-                      <a:tailEnd type="none" w="med" len="med"/>
-                    </a:lnL>
-                    <a:lnR w="12700" cap="flat" cmpd="sng" algn="ctr">
-                      <a:solidFill>
-                        <a:srgbClr val="232F48"/>
-                      </a:solidFill>
-                      <a:prstDash val="solid"/>
-                      <a:round/>
-                      <a:headEnd type="none" w="med" len="med"/>
-                      <a:tailEnd type="none" w="med" len="med"/>
-                    </a:lnR>
-                    <a:lnT w="12700" cap="flat" cmpd="sng" algn="ctr">
-                      <a:solidFill>
-                        <a:srgbClr val="232F48"/>
-                      </a:solidFill>
-                      <a:prstDash val="solid"/>
-                      <a:round/>
-                      <a:headEnd type="none" w="med" len="med"/>
-                      <a:tailEnd type="none" w="med" len="med"/>
-                    </a:lnT>
-                    <a:lnB w="12700" cap="flat" cmpd="sng" algn="ctr">
-                      <a:solidFill>
-                        <a:srgbClr val="232F48"/>
-                      </a:solidFill>
-                      <a:prstDash val="solid"/>
-                      <a:round/>
-                      <a:headEnd type="none" w="med" len="med"/>
-                      <a:tailEnd type="none" w="med" len="med"/>
-                    </a:lnB>
-                    <a:solidFill>
-                      <a:srgbClr val="121A2B"/>
-                    </a:solidFill>
-                  </a:tcPr>
-                </a:tc>
-              </a:tr>
-              <a:tr h="914400">
-                <a:tc>
-                  <a:txBody>
-                    <a:bodyPr/>
-                    <a:lstStyle/>
-                    <a:p>
-                      <a:pPr indent="0" marL="0">
-                        <a:buNone/>
-                      </a:pPr>
-                      <a:r>
-                        <a:rPr lang="en-US" sz="1100" b="1" dirty="0">
-                          <a:solidFill>
-                            <a:srgbClr val="F1F5F9"/>
-                          </a:solidFill>
-                          <a:latin typeface="Arial" pitchFamily="34" charset="0"/>
-                          <a:ea typeface="Arial" pitchFamily="34" charset="-122"/>
-                          <a:cs typeface="Arial" pitchFamily="34" charset="-120"/>
-                        </a:rPr>
-                        <a:t>GitHub Copilot / SWE-agent</a:t>
-                      </a:r>
-                      <a:endParaRPr lang="en-US" sz="1100" dirty="0">
-                        <a:latin typeface="Arial" charset="0"/>
-                        <a:ea typeface="Arial" charset="0"/>
-                        <a:cs typeface="Arial" charset="0"/>
-                      </a:endParaRPr>
-                    </a:p>
-                  </a:txBody>
-                  <a:tcPr marL="91440" marR="91440" marT="45720" marB="45720">
-                    <a:lnL w="12700" cap="flat" cmpd="sng" algn="ctr">
-                      <a:solidFill>
-                        <a:srgbClr val="232F48"/>
-                      </a:solidFill>
-                      <a:prstDash val="solid"/>
-                      <a:round/>
-                      <a:headEnd type="none" w="med" len="med"/>
-                      <a:tailEnd type="none" w="med" len="med"/>
-                    </a:lnL>
-                    <a:lnR w="12700" cap="flat" cmpd="sng" algn="ctr">
-                      <a:solidFill>
-                        <a:srgbClr val="232F48"/>
-                      </a:solidFill>
-                      <a:prstDash val="solid"/>
-                      <a:round/>
-                      <a:headEnd type="none" w="med" len="med"/>
-                      <a:tailEnd type="none" w="med" len="med"/>
-                    </a:lnR>
-                    <a:lnT w="12700" cap="flat" cmpd="sng" algn="ctr">
-                      <a:solidFill>
-                        <a:srgbClr val="232F48"/>
-                      </a:solidFill>
-                      <a:prstDash val="solid"/>
-                      <a:round/>
-                      <a:headEnd type="none" w="med" len="med"/>
-                      <a:tailEnd type="none" w="med" len="med"/>
-                    </a:lnT>
-                    <a:lnB w="12700" cap="flat" cmpd="sng" algn="ctr">
-                      <a:solidFill>
-                        <a:srgbClr val="232F48"/>
-                      </a:solidFill>
-                      <a:prstDash val="solid"/>
-                      <a:round/>
-                      <a:headEnd type="none" w="med" len="med"/>
-                      <a:tailEnd type="none" w="med" len="med"/>
-                    </a:lnB>
-                    <a:solidFill>
-                      <a:srgbClr val="121A2B"/>
-                    </a:solidFill>
-                  </a:tcPr>
-                </a:tc>
-                <a:tc>
-                  <a:txBody>
-                    <a:bodyPr/>
-                    <a:lstStyle/>
-                    <a:p>
-                      <a:pPr indent="0" marL="0">
-                        <a:buNone/>
-                      </a:pPr>
-                      <a:r>
-                        <a:rPr lang="en-US" sz="1100" dirty="0">
-                          <a:solidFill>
-                            <a:srgbClr val="F1F5F9"/>
-                          </a:solidFill>
-                          <a:latin typeface="Arial" pitchFamily="34" charset="0"/>
-                          <a:ea typeface="Arial" pitchFamily="34" charset="-122"/>
-                          <a:cs typeface="Arial" pitchFamily="34" charset="-120"/>
-                        </a:rPr>
-                        <a:t>Autonomous coding agents creating automated pull requests.</a:t>
-                      </a:r>
-                      <a:endParaRPr lang="en-US" sz="1100" dirty="0">
-                        <a:latin typeface="Arial" charset="0"/>
-                        <a:ea typeface="Arial" charset="0"/>
-                        <a:cs typeface="Arial" charset="0"/>
-                      </a:endParaRPr>
-                    </a:p>
-                  </a:txBody>
-                  <a:tcPr marL="91440" marR="91440" marT="45720" marB="45720">
-                    <a:lnL w="12700" cap="flat" cmpd="sng" algn="ctr">
-                      <a:solidFill>
-                        <a:srgbClr val="232F48"/>
-                      </a:solidFill>
-                      <a:prstDash val="solid"/>
-                      <a:round/>
-                      <a:headEnd type="none" w="med" len="med"/>
-                      <a:tailEnd type="none" w="med" len="med"/>
-                    </a:lnL>
-                    <a:lnR w="12700" cap="flat" cmpd="sng" algn="ctr">
-                      <a:solidFill>
-                        <a:srgbClr val="232F48"/>
-                      </a:solidFill>
-                      <a:prstDash val="solid"/>
-                      <a:round/>
-                      <a:headEnd type="none" w="med" len="med"/>
-                      <a:tailEnd type="none" w="med" len="med"/>
-                    </a:lnR>
-                    <a:lnT w="12700" cap="flat" cmpd="sng" algn="ctr">
-                      <a:solidFill>
-                        <a:srgbClr val="232F48"/>
-                      </a:solidFill>
-                      <a:prstDash val="solid"/>
-                      <a:round/>
-                      <a:headEnd type="none" w="med" len="med"/>
-                      <a:tailEnd type="none" w="med" len="med"/>
-                    </a:lnT>
-                    <a:lnB w="12700" cap="flat" cmpd="sng" algn="ctr">
-                      <a:solidFill>
-                        <a:srgbClr val="232F48"/>
-                      </a:solidFill>
-                      <a:prstDash val="solid"/>
-                      <a:round/>
-                      <a:headEnd type="none" w="med" len="med"/>
-                      <a:tailEnd type="none" w="med" len="med"/>
-                    </a:lnB>
-                    <a:solidFill>
-                      <a:srgbClr val="121A2B"/>
-                    </a:solidFill>
-                  </a:tcPr>
-                </a:tc>
-                <a:tc>
-                  <a:txBody>
-                    <a:bodyPr/>
-                    <a:lstStyle/>
-                    <a:p>
-                      <a:pPr indent="0" marL="0">
-                        <a:buNone/>
-                      </a:pPr>
-                      <a:r>
-                        <a:rPr lang="en-US" sz="1100" dirty="0">
-                          <a:solidFill>
-                            <a:srgbClr val="F1F5F9"/>
-                          </a:solidFill>
-                          <a:latin typeface="Arial" pitchFamily="34" charset="0"/>
-                          <a:ea typeface="Arial" pitchFamily="34" charset="-122"/>
-                          <a:cs typeface="Arial" pitchFamily="34" charset="-120"/>
-                        </a:rPr>
-                        <a:t>Do not compete as an autonomous patch agent.</a:t>
-                      </a:r>
-                      <a:endParaRPr lang="en-US" sz="1100" dirty="0">
-                        <a:latin typeface="Arial" charset="0"/>
-                        <a:ea typeface="Arial" charset="0"/>
-                        <a:cs typeface="Arial" charset="0"/>
-                      </a:endParaRPr>
-                    </a:p>
-                  </a:txBody>
-                  <a:tcPr marL="91440" marR="91440" marT="45720" marB="45720">
-                    <a:lnL w="12700" cap="flat" cmpd="sng" algn="ctr">
-                      <a:solidFill>
-                        <a:srgbClr val="232F48"/>
-                      </a:solidFill>
-                      <a:prstDash val="solid"/>
-                      <a:round/>
-                      <a:headEnd type="none" w="med" len="med"/>
-                      <a:tailEnd type="none" w="med" len="med"/>
-                    </a:lnL>
-                    <a:lnR w="12700" cap="flat" cmpd="sng" algn="ctr">
-                      <a:solidFill>
-                        <a:srgbClr val="232F48"/>
-                      </a:solidFill>
-                      <a:prstDash val="solid"/>
-                      <a:round/>
-                      <a:headEnd type="none" w="med" len="med"/>
-                      <a:tailEnd type="none" w="med" len="med"/>
-                    </a:lnR>
-                    <a:lnT w="12700" cap="flat" cmpd="sng" algn="ctr">
-                      <a:solidFill>
-                        <a:srgbClr val="232F48"/>
-                      </a:solidFill>
-                      <a:prstDash val="solid"/>
-                      <a:round/>
-                      <a:headEnd type="none" w="med" len="med"/>
-                      <a:tailEnd type="none" w="med" len="med"/>
-                    </a:lnT>
-                    <a:lnB w="12700" cap="flat" cmpd="sng" algn="ctr">
-                      <a:solidFill>
-                        <a:srgbClr val="232F48"/>
-                      </a:solidFill>
-                      <a:prstDash val="solid"/>
-                      <a:round/>
-                      <a:headEnd type="none" w="med" len="med"/>
-                      <a:tailEnd type="none" w="med" len="med"/>
-                    </a:lnB>
-                    <a:solidFill>
-                      <a:srgbClr val="121A2B"/>
-                    </a:solidFill>
-                  </a:tcPr>
-                </a:tc>
-                <a:tc>
-                  <a:txBody>
-                    <a:bodyPr/>
-                    <a:lstStyle/>
-                    <a:p>
-                      <a:pPr indent="0" marL="0">
-                        <a:buNone/>
-                      </a:pPr>
-                      <a:r>
-                        <a:rPr lang="en-US" sz="1100" dirty="0">
-                          <a:solidFill>
-                            <a:srgbClr val="F1F5F9"/>
-                          </a:solidFill>
-                          <a:latin typeface="Arial" pitchFamily="34" charset="0"/>
-                          <a:ea typeface="Arial" pitchFamily="34" charset="-122"/>
-                          <a:cs typeface="Arial" pitchFamily="34" charset="-120"/>
-                        </a:rPr>
-                        <a:t>Human contributor empowerment: verifiable truth trail &amp; test radar.</a:t>
-                      </a:r>
-                      <a:endParaRPr lang="en-US" sz="1100" dirty="0">
-                        <a:latin typeface="Arial" charset="0"/>
-                        <a:ea typeface="Arial" charset="0"/>
-                        <a:cs typeface="Arial" charset="0"/>
-                      </a:endParaRPr>
-                    </a:p>
-                  </a:txBody>
-                  <a:tcPr marL="91440" marR="91440" marT="45720" marB="45720">
-                    <a:lnL w="12700" cap="flat" cmpd="sng" algn="ctr">
-                      <a:solidFill>
-                        <a:srgbClr val="232F48"/>
-                      </a:solidFill>
-                      <a:prstDash val="solid"/>
-                      <a:round/>
-                      <a:headEnd type="none" w="med" len="med"/>
-                      <a:tailEnd type="none" w="med" len="med"/>
-                    </a:lnL>
-                    <a:lnR w="12700" cap="flat" cmpd="sng" algn="ctr">
-                      <a:solidFill>
-                        <a:srgbClr val="232F48"/>
-                      </a:solidFill>
-                      <a:prstDash val="solid"/>
-                      <a:round/>
-                      <a:headEnd type="none" w="med" len="med"/>
-                      <a:tailEnd type="none" w="med" len="med"/>
-                    </a:lnR>
-                    <a:lnT w="12700" cap="flat" cmpd="sng" algn="ctr">
-                      <a:solidFill>
-                        <a:srgbClr val="232F48"/>
-                      </a:solidFill>
-                      <a:prstDash val="solid"/>
-                      <a:round/>
-                      <a:headEnd type="none" w="med" len="med"/>
-                      <a:tailEnd type="none" w="med" len="med"/>
-                    </a:lnT>
-                    <a:lnB w="12700" cap="flat" cmpd="sng" algn="ctr">
-                      <a:solidFill>
-                        <a:srgbClr val="232F48"/>
-                      </a:solidFill>
-                      <a:prstDash val="solid"/>
-                      <a:round/>
-                      <a:headEnd type="none" w="med" len="med"/>
-                      <a:tailEnd type="none" w="med" len="med"/>
-                    </a:lnB>
-                    <a:solidFill>
-                      <a:srgbClr val="121A2B"/>
-                    </a:solidFill>
-                  </a:tcPr>
-                </a:tc>
-              </a:tr>
-            </a:tbl>
-          </a:graphicData>
-        </a:graphic>
-      </p:graphicFrame>
+      <p:sp>
+        <p:nvSpPr>
+          <p:cNvPr id="4" name="Text 2"/>
+          <p:cNvSpPr/>
+          <p:nvPr/>
+        </p:nvSpPr>
+        <p:spPr>
+          <a:xfrm>
+            <a:off x="676656" y="1335024"/>
+            <a:ext cx="10789920" cy="310896"/>
+          </a:xfrm>
+          <a:prstGeom prst="rect">
+            <a:avLst/>
+          </a:prstGeom>
+          <a:noFill/>
+          <a:ln/>
+        </p:spPr>
+        <p:txBody>
+          <a:bodyPr wrap="square" rtlCol="0" anchor="ctr"/>
+          <a:lstStyle/>
+          <a:p>
+            <a:pPr indent="0" marL="0">
+              <a:buNone/>
+            </a:pPr>
+            <a:r>
+              <a:rPr lang="en-US" sz="1400" dirty="0">
+                <a:solidFill>
+                  <a:srgbClr val="B5C0D3"/>
+                </a:solidFill>
+                <a:latin typeface="Arial" pitchFamily="34" charset="0"/>
+                <a:ea typeface="Arial" pitchFamily="34" charset="-122"/>
+                <a:cs typeface="Arial" pitchFamily="34" charset="-120"/>
+              </a:rPr>
+              <a:t>Turn a public GitHub issue into a reviewable plan with evidence—not guesswork.</a:t>
+            </a:r>
+            <a:endParaRPr lang="en-US" sz="1400" dirty="0"/>
+          </a:p>
+        </p:txBody>
+      </p:sp>
+      <p:sp>
+        <p:nvSpPr>
+          <p:cNvPr id="5" name="Shape 3"/>
+          <p:cNvSpPr/>
+          <p:nvPr/>
+        </p:nvSpPr>
+        <p:spPr>
+          <a:xfrm>
+            <a:off x="658368" y="1993392"/>
+            <a:ext cx="2048256" cy="2980944"/>
+          </a:xfrm>
+          <a:prstGeom prst="roundRect">
+            <a:avLst/>
+          </a:prstGeom>
+          <a:solidFill>
+            <a:srgbClr val="121A2B"/>
+          </a:solidFill>
+          <a:ln w="12700">
+            <a:solidFill>
+              <a:srgbClr val="2A3953"/>
+            </a:solidFill>
+            <a:prstDash val="solid"/>
+          </a:ln>
+        </p:spPr>
+      </p:sp>
+      <p:sp>
+        <p:nvSpPr>
+          <p:cNvPr id="6" name="Shape 4"/>
+          <p:cNvSpPr/>
+          <p:nvPr/>
+        </p:nvSpPr>
+        <p:spPr>
+          <a:xfrm>
+            <a:off x="676656" y="2011680"/>
+            <a:ext cx="2011680" cy="50292"/>
+          </a:xfrm>
+          <a:prstGeom prst="rect">
+            <a:avLst/>
+          </a:prstGeom>
+          <a:solidFill>
+            <a:srgbClr val="A78BFA"/>
+          </a:solidFill>
+          <a:ln w="12700">
+            <a:solidFill>
+              <a:srgbClr val="A78BFA"/>
+            </a:solidFill>
+            <a:prstDash val="solid"/>
+          </a:ln>
+        </p:spPr>
+      </p:sp>
+      <p:sp>
+        <p:nvSpPr>
+          <p:cNvPr id="7" name="Text 5"/>
+          <p:cNvSpPr/>
+          <p:nvPr/>
+        </p:nvSpPr>
+        <p:spPr>
+          <a:xfrm>
+            <a:off x="822960" y="2249424"/>
+            <a:ext cx="475488" cy="475488"/>
+          </a:xfrm>
+          <a:prstGeom prst="ellipse">
+            <a:avLst/>
+          </a:prstGeom>
+          <a:solidFill>
+            <a:srgbClr val="A78BFA"/>
+          </a:solidFill>
+          <a:ln/>
+        </p:spPr>
+        <p:txBody>
+          <a:bodyPr wrap="square" rtlCol="0" anchor="ctr"/>
+          <a:lstStyle/>
+          <a:p>
+            <a:pPr algn="ctr" indent="0" marL="0">
+              <a:buNone/>
+            </a:pPr>
+            <a:r>
+              <a:rPr lang="en-US" sz="1300" b="1" dirty="0">
+                <a:solidFill>
+                  <a:srgbClr val="0A0F1F"/>
+                </a:solidFill>
+                <a:latin typeface="Arial" pitchFamily="34" charset="0"/>
+                <a:ea typeface="Arial" pitchFamily="34" charset="-122"/>
+                <a:cs typeface="Arial" pitchFamily="34" charset="-120"/>
+              </a:rPr>
+              <a:t>01</a:t>
+            </a:r>
+            <a:endParaRPr lang="en-US" sz="1300" dirty="0"/>
+          </a:p>
+        </p:txBody>
+      </p:sp>
+      <p:sp>
+        <p:nvSpPr>
+          <p:cNvPr id="8" name="Text 6"/>
+          <p:cNvSpPr/>
+          <p:nvPr/>
+        </p:nvSpPr>
+        <p:spPr>
+          <a:xfrm>
+            <a:off x="822960" y="2907792"/>
+            <a:ext cx="1719072" cy="420624"/>
+          </a:xfrm>
+          <a:prstGeom prst="rect">
+            <a:avLst/>
+          </a:prstGeom>
+          <a:noFill/>
+          <a:ln/>
+        </p:spPr>
+        <p:txBody>
+          <a:bodyPr wrap="square" rtlCol="0" anchor="ctr"/>
+          <a:lstStyle/>
+          <a:p>
+            <a:pPr indent="0" marL="0">
+              <a:buNone/>
+            </a:pPr>
+            <a:r>
+              <a:rPr lang="en-US" sz="1700" b="1" dirty="0">
+                <a:solidFill>
+                  <a:srgbClr val="F1F5F9"/>
+                </a:solidFill>
+                <a:latin typeface="Arial" pitchFamily="34" charset="0"/>
+                <a:ea typeface="Arial" pitchFamily="34" charset="-122"/>
+                <a:cs typeface="Arial" pitchFamily="34" charset="-120"/>
+              </a:rPr>
+              <a:t>Submit issue</a:t>
+            </a:r>
+            <a:endParaRPr lang="en-US" sz="1700" dirty="0"/>
+          </a:p>
+        </p:txBody>
+      </p:sp>
+      <p:sp>
+        <p:nvSpPr>
+          <p:cNvPr id="9" name="Text 7"/>
+          <p:cNvSpPr/>
+          <p:nvPr/>
+        </p:nvSpPr>
+        <p:spPr>
+          <a:xfrm>
+            <a:off x="822960" y="3419856"/>
+            <a:ext cx="1719072" cy="1161288"/>
+          </a:xfrm>
+          <a:prstGeom prst="rect">
+            <a:avLst/>
+          </a:prstGeom>
+          <a:noFill/>
+          <a:ln/>
+        </p:spPr>
+        <p:txBody>
+          <a:bodyPr wrap="square" rtlCol="0" anchor="ctr"/>
+          <a:lstStyle/>
+          <a:p>
+            <a:pPr indent="0" marL="0">
+              <a:lnSpc>
+                <a:spcPts val="1600"/>
+              </a:lnSpc>
+              <a:buNone/>
+            </a:pPr>
+            <a:r>
+              <a:rPr lang="en-US" sz="1200" dirty="0">
+                <a:solidFill>
+                  <a:srgbClr val="B5C0D3"/>
+                </a:solidFill>
+                <a:latin typeface="Arial" pitchFamily="34" charset="0"/>
+                <a:ea typeface="Arial" pitchFamily="34" charset="-122"/>
+                <a:cs typeface="Arial" pitchFamily="34" charset="-120"/>
+              </a:rPr>
+              <a:t>Paste a public GitHub issue URL. Check issue status and context.</a:t>
+            </a:r>
+            <a:endParaRPr lang="en-US" sz="1200" dirty="0"/>
+          </a:p>
+        </p:txBody>
+      </p:sp>
+      <p:sp>
+        <p:nvSpPr>
+          <p:cNvPr id="10" name="Shape 8"/>
+          <p:cNvSpPr/>
+          <p:nvPr/>
+        </p:nvSpPr>
+        <p:spPr>
+          <a:xfrm>
+            <a:off x="2738628" y="3419856"/>
+            <a:ext cx="109728" cy="228600"/>
+          </a:xfrm>
+          <a:prstGeom prst="chevron">
+            <a:avLst/>
+          </a:prstGeom>
+          <a:solidFill>
+            <a:srgbClr val="2A3953"/>
+          </a:solidFill>
+          <a:ln w="12700">
+            <a:solidFill>
+              <a:srgbClr val="2A3953"/>
+            </a:solidFill>
+            <a:prstDash val="solid"/>
+          </a:ln>
+        </p:spPr>
+      </p:sp>
+      <p:sp>
+        <p:nvSpPr>
+          <p:cNvPr id="11" name="Shape 9"/>
+          <p:cNvSpPr/>
+          <p:nvPr/>
+        </p:nvSpPr>
+        <p:spPr>
+          <a:xfrm>
+            <a:off x="2871216" y="1993392"/>
+            <a:ext cx="2048256" cy="2980944"/>
+          </a:xfrm>
+          <a:prstGeom prst="roundRect">
+            <a:avLst/>
+          </a:prstGeom>
+          <a:solidFill>
+            <a:srgbClr val="121A2B"/>
+          </a:solidFill>
+          <a:ln w="12700">
+            <a:solidFill>
+              <a:srgbClr val="2A3953"/>
+            </a:solidFill>
+            <a:prstDash val="solid"/>
+          </a:ln>
+        </p:spPr>
+      </p:sp>
+      <p:sp>
+        <p:nvSpPr>
+          <p:cNvPr id="12" name="Shape 10"/>
+          <p:cNvSpPr/>
+          <p:nvPr/>
+        </p:nvSpPr>
+        <p:spPr>
+          <a:xfrm>
+            <a:off x="2889504" y="2011680"/>
+            <a:ext cx="2011680" cy="50292"/>
+          </a:xfrm>
+          <a:prstGeom prst="rect">
+            <a:avLst/>
+          </a:prstGeom>
+          <a:solidFill>
+            <a:srgbClr val="67E8F9"/>
+          </a:solidFill>
+          <a:ln w="12700">
+            <a:solidFill>
+              <a:srgbClr val="67E8F9"/>
+            </a:solidFill>
+            <a:prstDash val="solid"/>
+          </a:ln>
+        </p:spPr>
+      </p:sp>
+      <p:sp>
+        <p:nvSpPr>
+          <p:cNvPr id="13" name="Text 11"/>
+          <p:cNvSpPr/>
+          <p:nvPr/>
+        </p:nvSpPr>
+        <p:spPr>
+          <a:xfrm>
+            <a:off x="3035808" y="2249424"/>
+            <a:ext cx="475488" cy="475488"/>
+          </a:xfrm>
+          <a:prstGeom prst="ellipse">
+            <a:avLst/>
+          </a:prstGeom>
+          <a:solidFill>
+            <a:srgbClr val="67E8F9"/>
+          </a:solidFill>
+          <a:ln/>
+        </p:spPr>
+        <p:txBody>
+          <a:bodyPr wrap="square" rtlCol="0" anchor="ctr"/>
+          <a:lstStyle/>
+          <a:p>
+            <a:pPr algn="ctr" indent="0" marL="0">
+              <a:buNone/>
+            </a:pPr>
+            <a:r>
+              <a:rPr lang="en-US" sz="1300" b="1" dirty="0">
+                <a:solidFill>
+                  <a:srgbClr val="0A0F1F"/>
+                </a:solidFill>
+                <a:latin typeface="Arial" pitchFamily="34" charset="0"/>
+                <a:ea typeface="Arial" pitchFamily="34" charset="-122"/>
+                <a:cs typeface="Arial" pitchFamily="34" charset="-120"/>
+              </a:rPr>
+              <a:t>02</a:t>
+            </a:r>
+            <a:endParaRPr lang="en-US" sz="1300" dirty="0"/>
+          </a:p>
+        </p:txBody>
+      </p:sp>
+      <p:sp>
+        <p:nvSpPr>
+          <p:cNvPr id="14" name="Text 12"/>
+          <p:cNvSpPr/>
+          <p:nvPr/>
+        </p:nvSpPr>
+        <p:spPr>
+          <a:xfrm>
+            <a:off x="3035808" y="2907792"/>
+            <a:ext cx="1719072" cy="420624"/>
+          </a:xfrm>
+          <a:prstGeom prst="rect">
+            <a:avLst/>
+          </a:prstGeom>
+          <a:noFill/>
+          <a:ln/>
+        </p:spPr>
+        <p:txBody>
+          <a:bodyPr wrap="square" rtlCol="0" anchor="ctr"/>
+          <a:lstStyle/>
+          <a:p>
+            <a:pPr indent="0" marL="0">
+              <a:buNone/>
+            </a:pPr>
+            <a:r>
+              <a:rPr lang="en-US" sz="1700" b="1" dirty="0">
+                <a:solidFill>
+                  <a:srgbClr val="F1F5F9"/>
+                </a:solidFill>
+                <a:latin typeface="Arial" pitchFamily="34" charset="0"/>
+                <a:ea typeface="Arial" pitchFamily="34" charset="-122"/>
+                <a:cs typeface="Arial" pitchFamily="34" charset="-120"/>
+              </a:rPr>
+              <a:t>Bounded scan</a:t>
+            </a:r>
+            <a:endParaRPr lang="en-US" sz="1700" dirty="0"/>
+          </a:p>
+        </p:txBody>
+      </p:sp>
+      <p:sp>
+        <p:nvSpPr>
+          <p:cNvPr id="15" name="Text 13"/>
+          <p:cNvSpPr/>
+          <p:nvPr/>
+        </p:nvSpPr>
+        <p:spPr>
+          <a:xfrm>
+            <a:off x="3035808" y="3419856"/>
+            <a:ext cx="1719072" cy="1161288"/>
+          </a:xfrm>
+          <a:prstGeom prst="rect">
+            <a:avLst/>
+          </a:prstGeom>
+          <a:noFill/>
+          <a:ln/>
+        </p:spPr>
+        <p:txBody>
+          <a:bodyPr wrap="square" rtlCol="0" anchor="ctr"/>
+          <a:lstStyle/>
+          <a:p>
+            <a:pPr indent="0" marL="0">
+              <a:lnSpc>
+                <a:spcPts val="1600"/>
+              </a:lnSpc>
+              <a:buNone/>
+            </a:pPr>
+            <a:r>
+              <a:rPr lang="en-US" sz="1200" dirty="0">
+                <a:solidFill>
+                  <a:srgbClr val="B5C0D3"/>
+                </a:solidFill>
+                <a:latin typeface="Arial" pitchFamily="34" charset="0"/>
+                <a:ea typeface="Arial" pitchFamily="34" charset="-122"/>
+                <a:cs typeface="Arial" pitchFamily="34" charset="-120"/>
+              </a:rPr>
+              <a:t>Read repository files, manifests and docs within API limits.</a:t>
+            </a:r>
+            <a:endParaRPr lang="en-US" sz="1200" dirty="0"/>
+          </a:p>
+        </p:txBody>
+      </p:sp>
+      <p:sp>
+        <p:nvSpPr>
+          <p:cNvPr id="16" name="Shape 14"/>
+          <p:cNvSpPr/>
+          <p:nvPr/>
+        </p:nvSpPr>
+        <p:spPr>
+          <a:xfrm>
+            <a:off x="4951476" y="3419856"/>
+            <a:ext cx="109728" cy="228600"/>
+          </a:xfrm>
+          <a:prstGeom prst="chevron">
+            <a:avLst/>
+          </a:prstGeom>
+          <a:solidFill>
+            <a:srgbClr val="2A3953"/>
+          </a:solidFill>
+          <a:ln w="12700">
+            <a:solidFill>
+              <a:srgbClr val="2A3953"/>
+            </a:solidFill>
+            <a:prstDash val="solid"/>
+          </a:ln>
+        </p:spPr>
+      </p:sp>
+      <p:sp>
+        <p:nvSpPr>
+          <p:cNvPr id="17" name="Shape 15"/>
+          <p:cNvSpPr/>
+          <p:nvPr/>
+        </p:nvSpPr>
+        <p:spPr>
+          <a:xfrm>
+            <a:off x="5084064" y="1993392"/>
+            <a:ext cx="2048256" cy="2980944"/>
+          </a:xfrm>
+          <a:prstGeom prst="roundRect">
+            <a:avLst/>
+          </a:prstGeom>
+          <a:solidFill>
+            <a:srgbClr val="121A2B"/>
+          </a:solidFill>
+          <a:ln w="12700">
+            <a:solidFill>
+              <a:srgbClr val="2A3953"/>
+            </a:solidFill>
+            <a:prstDash val="solid"/>
+          </a:ln>
+        </p:spPr>
+      </p:sp>
+      <p:sp>
+        <p:nvSpPr>
+          <p:cNvPr id="18" name="Shape 16"/>
+          <p:cNvSpPr/>
+          <p:nvPr/>
+        </p:nvSpPr>
+        <p:spPr>
+          <a:xfrm>
+            <a:off x="5102352" y="2011680"/>
+            <a:ext cx="2011680" cy="50292"/>
+          </a:xfrm>
+          <a:prstGeom prst="rect">
+            <a:avLst/>
+          </a:prstGeom>
+          <a:solidFill>
+            <a:srgbClr val="5EEAD4"/>
+          </a:solidFill>
+          <a:ln w="12700">
+            <a:solidFill>
+              <a:srgbClr val="5EEAD4"/>
+            </a:solidFill>
+            <a:prstDash val="solid"/>
+          </a:ln>
+        </p:spPr>
+      </p:sp>
+      <p:sp>
+        <p:nvSpPr>
+          <p:cNvPr id="19" name="Text 17"/>
+          <p:cNvSpPr/>
+          <p:nvPr/>
+        </p:nvSpPr>
+        <p:spPr>
+          <a:xfrm>
+            <a:off x="5248656" y="2249424"/>
+            <a:ext cx="475488" cy="475488"/>
+          </a:xfrm>
+          <a:prstGeom prst="ellipse">
+            <a:avLst/>
+          </a:prstGeom>
+          <a:solidFill>
+            <a:srgbClr val="5EEAD4"/>
+          </a:solidFill>
+          <a:ln/>
+        </p:spPr>
+        <p:txBody>
+          <a:bodyPr wrap="square" rtlCol="0" anchor="ctr"/>
+          <a:lstStyle/>
+          <a:p>
+            <a:pPr algn="ctr" indent="0" marL="0">
+              <a:buNone/>
+            </a:pPr>
+            <a:r>
+              <a:rPr lang="en-US" sz="1300" b="1" dirty="0">
+                <a:solidFill>
+                  <a:srgbClr val="0A0F1F"/>
+                </a:solidFill>
+                <a:latin typeface="Arial" pitchFamily="34" charset="0"/>
+                <a:ea typeface="Arial" pitchFamily="34" charset="-122"/>
+                <a:cs typeface="Arial" pitchFamily="34" charset="-120"/>
+              </a:rPr>
+              <a:t>03</a:t>
+            </a:r>
+            <a:endParaRPr lang="en-US" sz="1300" dirty="0"/>
+          </a:p>
+        </p:txBody>
+      </p:sp>
+      <p:sp>
+        <p:nvSpPr>
+          <p:cNvPr id="20" name="Text 18"/>
+          <p:cNvSpPr/>
+          <p:nvPr/>
+        </p:nvSpPr>
+        <p:spPr>
+          <a:xfrm>
+            <a:off x="5248656" y="2907792"/>
+            <a:ext cx="1719072" cy="420624"/>
+          </a:xfrm>
+          <a:prstGeom prst="rect">
+            <a:avLst/>
+          </a:prstGeom>
+          <a:noFill/>
+          <a:ln/>
+        </p:spPr>
+        <p:txBody>
+          <a:bodyPr wrap="square" rtlCol="0" anchor="ctr"/>
+          <a:lstStyle/>
+          <a:p>
+            <a:pPr indent="0" marL="0">
+              <a:buNone/>
+            </a:pPr>
+            <a:r>
+              <a:rPr lang="en-US" sz="1700" b="1" dirty="0">
+                <a:solidFill>
+                  <a:srgbClr val="F1F5F9"/>
+                </a:solidFill>
+                <a:latin typeface="Arial" pitchFamily="34" charset="0"/>
+                <a:ea typeface="Arial" pitchFamily="34" charset="-122"/>
+                <a:cs typeface="Arial" pitchFamily="34" charset="-120"/>
+              </a:rPr>
+              <a:t>Draft contract</a:t>
+            </a:r>
+            <a:endParaRPr lang="en-US" sz="1700" dirty="0"/>
+          </a:p>
+        </p:txBody>
+      </p:sp>
+      <p:sp>
+        <p:nvSpPr>
+          <p:cNvPr id="21" name="Text 19"/>
+          <p:cNvSpPr/>
+          <p:nvPr/>
+        </p:nvSpPr>
+        <p:spPr>
+          <a:xfrm>
+            <a:off x="5248656" y="3419856"/>
+            <a:ext cx="1719072" cy="1161288"/>
+          </a:xfrm>
+          <a:prstGeom prst="rect">
+            <a:avLst/>
+          </a:prstGeom>
+          <a:noFill/>
+          <a:ln/>
+        </p:spPr>
+        <p:txBody>
+          <a:bodyPr wrap="square" rtlCol="0" anchor="ctr"/>
+          <a:lstStyle/>
+          <a:p>
+            <a:pPr indent="0" marL="0">
+              <a:lnSpc>
+                <a:spcPts val="1600"/>
+              </a:lnSpc>
+              <a:buNone/>
+            </a:pPr>
+            <a:r>
+              <a:rPr lang="en-US" sz="1200" dirty="0">
+                <a:solidFill>
+                  <a:srgbClr val="B5C0D3"/>
+                </a:solidFill>
+                <a:latin typeface="Arial" pitchFamily="34" charset="0"/>
+                <a:ea typeface="Arial" pitchFamily="34" charset="-122"/>
+                <a:cs typeface="Arial" pitchFamily="34" charset="-120"/>
+              </a:rPr>
+              <a:t>Gemma 4 extracts explicit criteria and labels inferred proposals.</a:t>
+            </a:r>
+            <a:endParaRPr lang="en-US" sz="1200" dirty="0"/>
+          </a:p>
+        </p:txBody>
+      </p:sp>
+      <p:sp>
+        <p:nvSpPr>
+          <p:cNvPr id="22" name="Shape 20"/>
+          <p:cNvSpPr/>
+          <p:nvPr/>
+        </p:nvSpPr>
+        <p:spPr>
+          <a:xfrm>
+            <a:off x="7164324" y="3419856"/>
+            <a:ext cx="109728" cy="228600"/>
+          </a:xfrm>
+          <a:prstGeom prst="chevron">
+            <a:avLst/>
+          </a:prstGeom>
+          <a:solidFill>
+            <a:srgbClr val="2A3953"/>
+          </a:solidFill>
+          <a:ln w="12700">
+            <a:solidFill>
+              <a:srgbClr val="2A3953"/>
+            </a:solidFill>
+            <a:prstDash val="solid"/>
+          </a:ln>
+        </p:spPr>
+      </p:sp>
+      <p:sp>
+        <p:nvSpPr>
+          <p:cNvPr id="23" name="Shape 21"/>
+          <p:cNvSpPr/>
+          <p:nvPr/>
+        </p:nvSpPr>
+        <p:spPr>
+          <a:xfrm>
+            <a:off x="7296912" y="1993392"/>
+            <a:ext cx="2048256" cy="2980944"/>
+          </a:xfrm>
+          <a:prstGeom prst="roundRect">
+            <a:avLst/>
+          </a:prstGeom>
+          <a:solidFill>
+            <a:srgbClr val="121A2B"/>
+          </a:solidFill>
+          <a:ln w="12700">
+            <a:solidFill>
+              <a:srgbClr val="2A3953"/>
+            </a:solidFill>
+            <a:prstDash val="solid"/>
+          </a:ln>
+        </p:spPr>
+      </p:sp>
+      <p:sp>
+        <p:nvSpPr>
+          <p:cNvPr id="24" name="Shape 22"/>
+          <p:cNvSpPr/>
+          <p:nvPr/>
+        </p:nvSpPr>
+        <p:spPr>
+          <a:xfrm>
+            <a:off x="7315200" y="2011680"/>
+            <a:ext cx="2011680" cy="50292"/>
+          </a:xfrm>
+          <a:prstGeom prst="rect">
+            <a:avLst/>
+          </a:prstGeom>
+          <a:solidFill>
+            <a:srgbClr val="A78BFA"/>
+          </a:solidFill>
+          <a:ln w="12700">
+            <a:solidFill>
+              <a:srgbClr val="A78BFA"/>
+            </a:solidFill>
+            <a:prstDash val="solid"/>
+          </a:ln>
+        </p:spPr>
+      </p:sp>
+      <p:sp>
+        <p:nvSpPr>
+          <p:cNvPr id="25" name="Text 23"/>
+          <p:cNvSpPr/>
+          <p:nvPr/>
+        </p:nvSpPr>
+        <p:spPr>
+          <a:xfrm>
+            <a:off x="7461504" y="2249424"/>
+            <a:ext cx="475488" cy="475488"/>
+          </a:xfrm>
+          <a:prstGeom prst="ellipse">
+            <a:avLst/>
+          </a:prstGeom>
+          <a:solidFill>
+            <a:srgbClr val="A78BFA"/>
+          </a:solidFill>
+          <a:ln/>
+        </p:spPr>
+        <p:txBody>
+          <a:bodyPr wrap="square" rtlCol="0" anchor="ctr"/>
+          <a:lstStyle/>
+          <a:p>
+            <a:pPr algn="ctr" indent="0" marL="0">
+              <a:buNone/>
+            </a:pPr>
+            <a:r>
+              <a:rPr lang="en-US" sz="1300" b="1" dirty="0">
+                <a:solidFill>
+                  <a:srgbClr val="0A0F1F"/>
+                </a:solidFill>
+                <a:latin typeface="Arial" pitchFamily="34" charset="0"/>
+                <a:ea typeface="Arial" pitchFamily="34" charset="-122"/>
+                <a:cs typeface="Arial" pitchFamily="34" charset="-120"/>
+              </a:rPr>
+              <a:t>04</a:t>
+            </a:r>
+            <a:endParaRPr lang="en-US" sz="1300" dirty="0"/>
+          </a:p>
+        </p:txBody>
+      </p:sp>
+      <p:sp>
+        <p:nvSpPr>
+          <p:cNvPr id="26" name="Text 24"/>
+          <p:cNvSpPr/>
+          <p:nvPr/>
+        </p:nvSpPr>
+        <p:spPr>
+          <a:xfrm>
+            <a:off x="7461504" y="2907792"/>
+            <a:ext cx="1719072" cy="420624"/>
+          </a:xfrm>
+          <a:prstGeom prst="rect">
+            <a:avLst/>
+          </a:prstGeom>
+          <a:noFill/>
+          <a:ln/>
+        </p:spPr>
+        <p:txBody>
+          <a:bodyPr wrap="square" rtlCol="0" anchor="ctr"/>
+          <a:lstStyle/>
+          <a:p>
+            <a:pPr indent="0" marL="0">
+              <a:buNone/>
+            </a:pPr>
+            <a:r>
+              <a:rPr lang="en-US" sz="1700" b="1" dirty="0">
+                <a:solidFill>
+                  <a:srgbClr val="F1F5F9"/>
+                </a:solidFill>
+                <a:latin typeface="Arial" pitchFamily="34" charset="0"/>
+                <a:ea typeface="Arial" pitchFamily="34" charset="-122"/>
+                <a:cs typeface="Arial" pitchFamily="34" charset="-120"/>
+              </a:rPr>
+              <a:t>Trace evidence</a:t>
+            </a:r>
+            <a:endParaRPr lang="en-US" sz="1700" dirty="0"/>
+          </a:p>
+        </p:txBody>
+      </p:sp>
+      <p:sp>
+        <p:nvSpPr>
+          <p:cNvPr id="27" name="Text 25"/>
+          <p:cNvSpPr/>
+          <p:nvPr/>
+        </p:nvSpPr>
+        <p:spPr>
+          <a:xfrm>
+            <a:off x="7461504" y="3419856"/>
+            <a:ext cx="1719072" cy="1161288"/>
+          </a:xfrm>
+          <a:prstGeom prst="rect">
+            <a:avLst/>
+          </a:prstGeom>
+          <a:noFill/>
+          <a:ln/>
+        </p:spPr>
+        <p:txBody>
+          <a:bodyPr wrap="square" rtlCol="0" anchor="ctr"/>
+          <a:lstStyle/>
+          <a:p>
+            <a:pPr indent="0" marL="0">
+              <a:lnSpc>
+                <a:spcPts val="1600"/>
+              </a:lnSpc>
+              <a:buNone/>
+            </a:pPr>
+            <a:r>
+              <a:rPr lang="en-US" sz="1200" dirty="0">
+                <a:solidFill>
+                  <a:srgbClr val="B5C0D3"/>
+                </a:solidFill>
+                <a:latin typeface="Arial" pitchFamily="34" charset="0"/>
+                <a:ea typeface="Arial" pitchFamily="34" charset="-122"/>
+                <a:cs typeface="Arial" pitchFamily="34" charset="-120"/>
+              </a:rPr>
+              <a:t>Map criteria to candidate source/test files and documented commands.</a:t>
+            </a:r>
+            <a:endParaRPr lang="en-US" sz="1200" dirty="0"/>
+          </a:p>
+        </p:txBody>
+      </p:sp>
+      <p:sp>
+        <p:nvSpPr>
+          <p:cNvPr id="28" name="Shape 26"/>
+          <p:cNvSpPr/>
+          <p:nvPr/>
+        </p:nvSpPr>
+        <p:spPr>
+          <a:xfrm>
+            <a:off x="9377172" y="3419856"/>
+            <a:ext cx="109728" cy="228600"/>
+          </a:xfrm>
+          <a:prstGeom prst="chevron">
+            <a:avLst/>
+          </a:prstGeom>
+          <a:solidFill>
+            <a:srgbClr val="2A3953"/>
+          </a:solidFill>
+          <a:ln w="12700">
+            <a:solidFill>
+              <a:srgbClr val="2A3953"/>
+            </a:solidFill>
+            <a:prstDash val="solid"/>
+          </a:ln>
+        </p:spPr>
+      </p:sp>
+      <p:sp>
+        <p:nvSpPr>
+          <p:cNvPr id="29" name="Shape 27"/>
+          <p:cNvSpPr/>
+          <p:nvPr/>
+        </p:nvSpPr>
+        <p:spPr>
+          <a:xfrm>
+            <a:off x="9509760" y="1993392"/>
+            <a:ext cx="2048256" cy="2980944"/>
+          </a:xfrm>
+          <a:prstGeom prst="roundRect">
+            <a:avLst/>
+          </a:prstGeom>
+          <a:solidFill>
+            <a:srgbClr val="121A2B"/>
+          </a:solidFill>
+          <a:ln w="12700">
+            <a:solidFill>
+              <a:srgbClr val="2A3953"/>
+            </a:solidFill>
+            <a:prstDash val="solid"/>
+          </a:ln>
+        </p:spPr>
+      </p:sp>
+      <p:sp>
+        <p:nvSpPr>
+          <p:cNvPr id="30" name="Shape 28"/>
+          <p:cNvSpPr/>
+          <p:nvPr/>
+        </p:nvSpPr>
+        <p:spPr>
+          <a:xfrm>
+            <a:off x="9528048" y="2011680"/>
+            <a:ext cx="2011680" cy="50292"/>
+          </a:xfrm>
+          <a:prstGeom prst="rect">
+            <a:avLst/>
+          </a:prstGeom>
+          <a:solidFill>
+            <a:srgbClr val="67E8F9"/>
+          </a:solidFill>
+          <a:ln w="12700">
+            <a:solidFill>
+              <a:srgbClr val="67E8F9"/>
+            </a:solidFill>
+            <a:prstDash val="solid"/>
+          </a:ln>
+        </p:spPr>
+      </p:sp>
+      <p:sp>
+        <p:nvSpPr>
+          <p:cNvPr id="31" name="Text 29"/>
+          <p:cNvSpPr/>
+          <p:nvPr/>
+        </p:nvSpPr>
+        <p:spPr>
+          <a:xfrm>
+            <a:off x="9674352" y="2249424"/>
+            <a:ext cx="475488" cy="475488"/>
+          </a:xfrm>
+          <a:prstGeom prst="ellipse">
+            <a:avLst/>
+          </a:prstGeom>
+          <a:solidFill>
+            <a:srgbClr val="67E8F9"/>
+          </a:solidFill>
+          <a:ln/>
+        </p:spPr>
+        <p:txBody>
+          <a:bodyPr wrap="square" rtlCol="0" anchor="ctr"/>
+          <a:lstStyle/>
+          <a:p>
+            <a:pPr algn="ctr" indent="0" marL="0">
+              <a:buNone/>
+            </a:pPr>
+            <a:r>
+              <a:rPr lang="en-US" sz="1300" b="1" dirty="0">
+                <a:solidFill>
+                  <a:srgbClr val="0A0F1F"/>
+                </a:solidFill>
+                <a:latin typeface="Arial" pitchFamily="34" charset="0"/>
+                <a:ea typeface="Arial" pitchFamily="34" charset="-122"/>
+                <a:cs typeface="Arial" pitchFamily="34" charset="-120"/>
+              </a:rPr>
+              <a:t>05</a:t>
+            </a:r>
+            <a:endParaRPr lang="en-US" sz="1300" dirty="0"/>
+          </a:p>
+        </p:txBody>
+      </p:sp>
+      <p:sp>
+        <p:nvSpPr>
+          <p:cNvPr id="32" name="Text 30"/>
+          <p:cNvSpPr/>
+          <p:nvPr/>
+        </p:nvSpPr>
+        <p:spPr>
+          <a:xfrm>
+            <a:off x="9674352" y="2907792"/>
+            <a:ext cx="1719072" cy="420624"/>
+          </a:xfrm>
+          <a:prstGeom prst="rect">
+            <a:avLst/>
+          </a:prstGeom>
+          <a:noFill/>
+          <a:ln/>
+        </p:spPr>
+        <p:txBody>
+          <a:bodyPr wrap="square" rtlCol="0" anchor="ctr"/>
+          <a:lstStyle/>
+          <a:p>
+            <a:pPr indent="0" marL="0">
+              <a:buNone/>
+            </a:pPr>
+            <a:r>
+              <a:rPr lang="en-US" sz="1700" b="1" dirty="0">
+                <a:solidFill>
+                  <a:srgbClr val="F1F5F9"/>
+                </a:solidFill>
+                <a:latin typeface="Arial" pitchFamily="34" charset="0"/>
+                <a:ea typeface="Arial" pitchFamily="34" charset="-122"/>
+                <a:cs typeface="Arial" pitchFamily="34" charset="-120"/>
+              </a:rPr>
+              <a:t>Verify &amp; export</a:t>
+            </a:r>
+            <a:endParaRPr lang="en-US" sz="1700" dirty="0"/>
+          </a:p>
+        </p:txBody>
+      </p:sp>
+      <p:sp>
+        <p:nvSpPr>
+          <p:cNvPr id="33" name="Text 31"/>
+          <p:cNvSpPr/>
+          <p:nvPr/>
+        </p:nvSpPr>
+        <p:spPr>
+          <a:xfrm>
+            <a:off x="9674352" y="3419856"/>
+            <a:ext cx="1719072" cy="1161288"/>
+          </a:xfrm>
+          <a:prstGeom prst="rect">
+            <a:avLst/>
+          </a:prstGeom>
+          <a:noFill/>
+          <a:ln/>
+        </p:spPr>
+        <p:txBody>
+          <a:bodyPr wrap="square" rtlCol="0" anchor="ctr"/>
+          <a:lstStyle/>
+          <a:p>
+            <a:pPr indent="0" marL="0">
+              <a:lnSpc>
+                <a:spcPts val="1600"/>
+              </a:lnSpc>
+              <a:buNone/>
+            </a:pPr>
+            <a:r>
+              <a:rPr lang="en-US" sz="1200" dirty="0">
+                <a:solidFill>
+                  <a:srgbClr val="B5C0D3"/>
+                </a:solidFill>
+                <a:latin typeface="Arial" pitchFamily="34" charset="0"/>
+                <a:ea typeface="Arial" pitchFamily="34" charset="-122"/>
+                <a:cs typeface="Arial" pitchFamily="34" charset="-120"/>
+              </a:rPr>
+              <a:t>Claim Gate rejects fabricated paths; export a Proof Bundle and handoff.</a:t>
+            </a:r>
+            <a:endParaRPr lang="en-US" sz="1200" dirty="0"/>
+          </a:p>
+        </p:txBody>
+      </p:sp>
+      <p:sp>
+        <p:nvSpPr>
+          <p:cNvPr id="34" name="Shape 32"/>
+          <p:cNvSpPr/>
+          <p:nvPr/>
+        </p:nvSpPr>
+        <p:spPr>
+          <a:xfrm>
+            <a:off x="658368" y="5285232"/>
+            <a:ext cx="10881360" cy="713232"/>
+          </a:xfrm>
+          <a:prstGeom prst="roundRect">
+            <a:avLst/>
+          </a:prstGeom>
+          <a:solidFill>
+            <a:srgbClr val="141E31"/>
+          </a:solidFill>
+          <a:ln w="12700">
+            <a:solidFill>
+              <a:srgbClr val="2A3953"/>
+            </a:solidFill>
+            <a:prstDash val="solid"/>
+          </a:ln>
+        </p:spPr>
+      </p:sp>
+      <p:sp>
+        <p:nvSpPr>
+          <p:cNvPr id="35" name="Text 33"/>
+          <p:cNvSpPr/>
+          <p:nvPr/>
+        </p:nvSpPr>
+        <p:spPr>
+          <a:xfrm>
+            <a:off x="896112" y="5495544"/>
+            <a:ext cx="1965960" cy="228600"/>
+          </a:xfrm>
+          <a:prstGeom prst="rect">
+            <a:avLst/>
+          </a:prstGeom>
+          <a:noFill/>
+          <a:ln/>
+        </p:spPr>
+        <p:txBody>
+          <a:bodyPr wrap="square" rtlCol="0" anchor="ctr"/>
+          <a:lstStyle/>
+          <a:p>
+            <a:pPr indent="0" marL="0">
+              <a:buNone/>
+            </a:pPr>
+            <a:r>
+              <a:rPr lang="en-US" sz="1200" b="1" dirty="0">
+                <a:solidFill>
+                  <a:srgbClr val="67E8F9"/>
+                </a:solidFill>
+                <a:latin typeface="Arial" pitchFamily="34" charset="0"/>
+                <a:ea typeface="Arial" pitchFamily="34" charset="-122"/>
+                <a:cs typeface="Arial" pitchFamily="34" charset="-120"/>
+              </a:rPr>
+              <a:t>GEMMA 4 PROPOSES</a:t>
+            </a:r>
+            <a:endParaRPr lang="en-US" sz="1200" dirty="0"/>
+          </a:p>
+        </p:txBody>
+      </p:sp>
+      <p:sp>
+        <p:nvSpPr>
+          <p:cNvPr id="36" name="Text 34"/>
+          <p:cNvSpPr/>
+          <p:nvPr/>
+        </p:nvSpPr>
+        <p:spPr>
+          <a:xfrm>
+            <a:off x="2788920" y="5472684"/>
+            <a:ext cx="182880" cy="274320"/>
+          </a:xfrm>
+          <a:prstGeom prst="rect">
+            <a:avLst/>
+          </a:prstGeom>
+          <a:noFill/>
+          <a:ln/>
+        </p:spPr>
+        <p:txBody>
+          <a:bodyPr wrap="square" rtlCol="0" anchor="ctr"/>
+          <a:lstStyle/>
+          <a:p>
+            <a:pPr algn="ctr" indent="0" marL="0">
+              <a:buNone/>
+            </a:pPr>
+            <a:r>
+              <a:rPr lang="en-US" sz="1600" b="1" dirty="0">
+                <a:solidFill>
+                  <a:srgbClr val="B5C0D3"/>
+                </a:solidFill>
+                <a:latin typeface="Arial" pitchFamily="34" charset="0"/>
+                <a:ea typeface="Arial" pitchFamily="34" charset="-122"/>
+                <a:cs typeface="Arial" pitchFamily="34" charset="-120"/>
+              </a:rPr>
+              <a:t>•</a:t>
+            </a:r>
+            <a:endParaRPr lang="en-US" sz="1600" dirty="0"/>
+          </a:p>
+        </p:txBody>
+      </p:sp>
+      <p:sp>
+        <p:nvSpPr>
+          <p:cNvPr id="37" name="Text 35"/>
+          <p:cNvSpPr/>
+          <p:nvPr/>
+        </p:nvSpPr>
+        <p:spPr>
+          <a:xfrm>
+            <a:off x="3127248" y="5495544"/>
+            <a:ext cx="2331720" cy="228600"/>
+          </a:xfrm>
+          <a:prstGeom prst="rect">
+            <a:avLst/>
+          </a:prstGeom>
+          <a:noFill/>
+          <a:ln/>
+        </p:spPr>
+        <p:txBody>
+          <a:bodyPr wrap="square" rtlCol="0" anchor="ctr"/>
+          <a:lstStyle/>
+          <a:p>
+            <a:pPr indent="0" marL="0">
+              <a:buNone/>
+            </a:pPr>
+            <a:r>
+              <a:rPr lang="en-US" sz="1200" b="1" dirty="0">
+                <a:solidFill>
+                  <a:srgbClr val="5EEAD4"/>
+                </a:solidFill>
+                <a:latin typeface="Arial" pitchFamily="34" charset="0"/>
+                <a:ea typeface="Arial" pitchFamily="34" charset="-122"/>
+                <a:cs typeface="Arial" pitchFamily="34" charset="-120"/>
+              </a:rPr>
+              <a:t>CLAIM GATE VERIFIES</a:t>
+            </a:r>
+            <a:endParaRPr lang="en-US" sz="1200" dirty="0"/>
+          </a:p>
+        </p:txBody>
+      </p:sp>
+      <p:sp>
+        <p:nvSpPr>
+          <p:cNvPr id="38" name="Text 36"/>
+          <p:cNvSpPr/>
+          <p:nvPr/>
+        </p:nvSpPr>
+        <p:spPr>
+          <a:xfrm>
+            <a:off x="5495544" y="5472684"/>
+            <a:ext cx="182880" cy="274320"/>
+          </a:xfrm>
+          <a:prstGeom prst="rect">
+            <a:avLst/>
+          </a:prstGeom>
+          <a:noFill/>
+          <a:ln/>
+        </p:spPr>
+        <p:txBody>
+          <a:bodyPr wrap="square" rtlCol="0" anchor="ctr"/>
+          <a:lstStyle/>
+          <a:p>
+            <a:pPr algn="ctr" indent="0" marL="0">
+              <a:buNone/>
+            </a:pPr>
+            <a:r>
+              <a:rPr lang="en-US" sz="1600" b="1" dirty="0">
+                <a:solidFill>
+                  <a:srgbClr val="B5C0D3"/>
+                </a:solidFill>
+                <a:latin typeface="Arial" pitchFamily="34" charset="0"/>
+                <a:ea typeface="Arial" pitchFamily="34" charset="-122"/>
+                <a:cs typeface="Arial" pitchFamily="34" charset="-120"/>
+              </a:rPr>
+              <a:t>•</a:t>
+            </a:r>
+            <a:endParaRPr lang="en-US" sz="1600" dirty="0"/>
+          </a:p>
+        </p:txBody>
+      </p:sp>
+      <p:sp>
+        <p:nvSpPr>
+          <p:cNvPr id="39" name="Text 37"/>
+          <p:cNvSpPr/>
+          <p:nvPr/>
+        </p:nvSpPr>
+        <p:spPr>
+          <a:xfrm>
+            <a:off x="5833872" y="5495544"/>
+            <a:ext cx="2331720" cy="228600"/>
+          </a:xfrm>
+          <a:prstGeom prst="rect">
+            <a:avLst/>
+          </a:prstGeom>
+          <a:noFill/>
+          <a:ln/>
+        </p:spPr>
+        <p:txBody>
+          <a:bodyPr wrap="square" rtlCol="0" anchor="ctr"/>
+          <a:lstStyle/>
+          <a:p>
+            <a:pPr indent="0" marL="0">
+              <a:buNone/>
+            </a:pPr>
+            <a:r>
+              <a:rPr lang="en-US" sz="1200" b="1" dirty="0">
+                <a:solidFill>
+                  <a:srgbClr val="A78BFA"/>
+                </a:solidFill>
+                <a:latin typeface="Arial" pitchFamily="34" charset="0"/>
+                <a:ea typeface="Arial" pitchFamily="34" charset="-122"/>
+                <a:cs typeface="Arial" pitchFamily="34" charset="-120"/>
+              </a:rPr>
+              <a:t>CONTRIBUTOR DECIDES</a:t>
+            </a:r>
+            <a:endParaRPr lang="en-US" sz="1200" dirty="0"/>
+          </a:p>
+        </p:txBody>
+      </p:sp>
+      <p:sp>
+        <p:nvSpPr>
+          <p:cNvPr id="40" name="Text 38"/>
+          <p:cNvSpPr/>
+          <p:nvPr/>
+        </p:nvSpPr>
+        <p:spPr>
+          <a:xfrm>
+            <a:off x="8028432" y="5468112"/>
+            <a:ext cx="3246120" cy="310896"/>
+          </a:xfrm>
+          <a:prstGeom prst="rect">
+            <a:avLst/>
+          </a:prstGeom>
+          <a:noFill/>
+          <a:ln/>
+        </p:spPr>
+        <p:txBody>
+          <a:bodyPr wrap="square" rtlCol="0" anchor="ctr"/>
+          <a:lstStyle/>
+          <a:p>
+            <a:pPr indent="0" marL="0">
+              <a:buNone/>
+            </a:pPr>
+            <a:r>
+              <a:rPr lang="en-US" sz="1000" dirty="0">
+                <a:solidFill>
+                  <a:srgbClr val="B5C0D3"/>
+                </a:solidFill>
+                <a:latin typeface="Arial" pitchFamily="34" charset="0"/>
+                <a:ea typeface="Arial" pitchFamily="34" charset="-122"/>
+                <a:cs typeface="Arial" pitchFamily="34" charset="-120"/>
+              </a:rPr>
+              <a:t>Scans are bounded; unverified evidence stays explicitly uncertain.</a:t>
+            </a:r>
+            <a:endParaRPr lang="en-US" sz="1000" dirty="0"/>
+          </a:p>
+        </p:txBody>
+      </p:sp>
+      <p:sp>
+        <p:nvSpPr>
+          <p:cNvPr id="41" name="Text 39"/>
+          <p:cNvSpPr/>
+          <p:nvPr/>
+        </p:nvSpPr>
+        <p:spPr>
+          <a:xfrm>
+            <a:off x="658368" y="6510528"/>
+            <a:ext cx="5120640" cy="146304"/>
+          </a:xfrm>
+          <a:prstGeom prst="rect">
+            <a:avLst/>
+          </a:prstGeom>
+          <a:noFill/>
+          <a:ln/>
+        </p:spPr>
+        <p:txBody>
+          <a:bodyPr wrap="square" rtlCol="0" anchor="ctr"/>
+          <a:lstStyle/>
+          <a:p>
+            <a:pPr indent="0" marL="0">
+              <a:buNone/>
+            </a:pPr>
+            <a:r>
+              <a:rPr lang="en-US" sz="800" dirty="0">
+                <a:solidFill>
+                  <a:srgbClr val="B5C0D3"/>
+                </a:solidFill>
+                <a:latin typeface="Arial" pitchFamily="34" charset="0"/>
+                <a:ea typeface="Arial" pitchFamily="34" charset="-122"/>
+                <a:cs typeface="Arial" pitchFamily="34" charset="-120"/>
+              </a:rPr>
+              <a:t>ISSUELIFT  •  HACKTOBERFEST 2026</a:t>
+            </a:r>
+            <a:endParaRPr lang="en-US" sz="800" dirty="0"/>
+          </a:p>
+        </p:txBody>
+      </p:sp>
+      <p:sp>
+        <p:nvSpPr>
+          <p:cNvPr id="42" name="Text 40"/>
+          <p:cNvSpPr/>
+          <p:nvPr/>
+        </p:nvSpPr>
+        <p:spPr>
+          <a:xfrm>
+            <a:off x="11283696" y="6492240"/>
+            <a:ext cx="201168" cy="164592"/>
+          </a:xfrm>
+          <a:prstGeom prst="rect">
+            <a:avLst/>
+          </a:prstGeom>
+          <a:noFill/>
+          <a:ln/>
+        </p:spPr>
+        <p:txBody>
+          <a:bodyPr wrap="square" rtlCol="0" anchor="ctr"/>
+          <a:lstStyle/>
+          <a:p>
+            <a:pPr algn="r" indent="0" marL="0">
+              <a:buNone/>
+            </a:pPr>
+            <a:r>
+              <a:rPr lang="en-US" sz="800" dirty="0">
+                <a:solidFill>
+                  <a:srgbClr val="B5C0D3"/>
+                </a:solidFill>
+                <a:latin typeface="Arial" pitchFamily="34" charset="0"/>
+                <a:ea typeface="Arial" pitchFamily="34" charset="-122"/>
+                <a:cs typeface="Arial" pitchFamily="34" charset="-120"/>
+              </a:rPr>
+              <a:t>2</a:t>
+            </a:r>
+            <a:endParaRPr lang="en-US" sz="800" dirty="0"/>
+          </a:p>
+        </p:txBody>
+      </p:sp>
     </p:spTree>
   </p:cSld>
   <p:clrMapOvr>

</xml_diff>

<commit_message>
fix: reconcile proof bundle evidence and finalize demo
</commit_message>
<xml_diff>
--- a/submission/IssueLift_Submission.pptx
+++ b/submission/IssueLift_Submission.pptx
@@ -4779,7 +4779,7 @@
                 <a:ea typeface="Arial" pitchFamily="34" charset="-122"/>
                 <a:cs typeface="Arial" pitchFamily="34" charset="-120"/>
               </a:rPr>
-              <a:t>*ProofBench evaluates 7 deterministic guardrail fixtures in eval/fixtures/ — distinct from the 78 unit tests in tests/ (Vitest).*</a:t>
+              <a:t>*ProofBench evaluates 7 deterministic guardrail fixtures in eval/fixtures/ — distinct from the 80 unit tests in tests/ (Vitest).*</a:t>
             </a:r>
             <a:endParaRPr lang="en-US" sz="1100" dirty="0"/>
           </a:p>
@@ -7739,7 +7739,7 @@
                           <a:ea typeface="Arial" pitchFamily="34" charset="-122"/>
                           <a:cs typeface="Arial" pitchFamily="34" charset="-120"/>
                         </a:rPr>
-                        <a:t>README.md verified; 78 unit tests passing across 4 suites (vitest in tests/)</a:t>
+                        <a:t>README.md verified; 80 unit tests passing across 4 suites (vitest in tests/)</a:t>
                       </a:r>
                       <a:endParaRPr lang="en-US" sz="1000" dirty="0">
                         <a:latin typeface="Arial" charset="0"/>
@@ -7807,7 +7807,7 @@
                           <a:ea typeface="Arial" pitchFamily="34" charset="-122"/>
                           <a:cs typeface="Arial" pitchFamily="34" charset="-120"/>
                         </a:rPr>
-                        <a:t>PASS (78/78 Passing)</a:t>
+                        <a:t>PASS (80/80 Passing)</a:t>
                       </a:r>
                       <a:endParaRPr lang="en-US" sz="1000" dirty="0">
                         <a:latin typeface="Arial" charset="0"/>

</xml_diff>